<commit_message>
updating week 2 slides
</commit_message>
<xml_diff>
--- a/week 2/Intro to Data Science — Week 2 Python for Data Work.pptx
+++ b/week 2/Intro to Data Science — Week 2 Python for Data Work.pptx
@@ -3283,6 +3283,13 @@
   <p:clrMapOvr>
     <a:masterClrMapping/>
   </p:clrMapOvr>
+  <p:timing>
+    <p:tnLst>
+      <p:par>
+        <p:cTn id="1" dur="indefinite" restart="never" nodeType="tmRoot"/>
+      </p:par>
+    </p:tnLst>
+  </p:timing>
 </p:sld>
 </file>
 
@@ -3609,6 +3616,13 @@
   <p:clrMapOvr>
     <a:masterClrMapping/>
   </p:clrMapOvr>
+  <p:timing>
+    <p:tnLst>
+      <p:par>
+        <p:cTn id="1" dur="indefinite" restart="never" nodeType="tmRoot"/>
+      </p:par>
+    </p:tnLst>
+  </p:timing>
 </p:sld>
 </file>
 
@@ -4345,11 +4359,173 @@
           </a:p>
         </p:txBody>
       </p:sp>
+      <p:sp>
+        <p:nvSpPr>
+          <p:cNvPr id="17" name="Text 1"/>
+          <p:cNvSpPr/>
+          <p:nvPr/>
+        </p:nvSpPr>
+        <p:spPr>
+          <a:xfrm>
+            <a:off x="815975" y="4471393"/>
+            <a:ext cx="10566400" cy="1160480"/>
+          </a:xfrm>
+          <a:prstGeom prst="roundRect">
+            <a:avLst>
+              <a:gd name="adj" fmla="val 5993"/>
+            </a:avLst>
+          </a:prstGeom>
+          <a:solidFill>
+            <a:srgbClr val="1B2A41"/>
+          </a:solidFill>
+          <a:ln/>
+        </p:spPr>
+        <p:txBody>
+          <a:bodyPr wrap="square" lIns="173442" tIns="173442" rIns="0" bIns="148042" rtlCol="0" anchor="t">
+            <a:normAutofit/>
+          </a:bodyPr>
+          <a:lstStyle/>
+          <a:p>
+            <a:pPr marL="0" indent="0" algn="l">
+              <a:lnSpc>
+                <a:spcPts val="2030"/>
+              </a:lnSpc>
+              <a:buNone/>
+            </a:pPr>
+            <a:r>
+              <a:rPr lang="en-US" sz="1400" dirty="0">
+                <a:solidFill>
+                  <a:srgbClr val="F7F5EF"/>
+                </a:solidFill>
+                <a:latin typeface="Courier New" pitchFamily="49" charset="0"/>
+                <a:ea typeface="Courier New" pitchFamily="49" charset="-122"/>
+                <a:cs typeface="Courier New" pitchFamily="49" charset="-120"/>
+              </a:rPr>
+              <a:t>def </a:t>
+            </a:r>
+            <a:r>
+              <a:rPr lang="en-US" sz="1400" dirty="0" err="1" smtClean="0">
+                <a:solidFill>
+                  <a:srgbClr val="F7F5EF"/>
+                </a:solidFill>
+                <a:latin typeface="Courier New" pitchFamily="49" charset="0"/>
+                <a:ea typeface="Courier New" pitchFamily="49" charset="-122"/>
+                <a:cs typeface="Courier New" pitchFamily="49" charset="-120"/>
+              </a:rPr>
+              <a:t>is_missing</a:t>
+            </a:r>
+            <a:r>
+              <a:rPr lang="en-US" sz="1400" dirty="0" smtClean="0">
+                <a:solidFill>
+                  <a:srgbClr val="F7F5EF"/>
+                </a:solidFill>
+                <a:latin typeface="Courier New" pitchFamily="49" charset="0"/>
+                <a:ea typeface="Courier New" pitchFamily="49" charset="-122"/>
+                <a:cs typeface="Courier New" pitchFamily="49" charset="-120"/>
+              </a:rPr>
+              <a:t>(</a:t>
+            </a:r>
+            <a:r>
+              <a:rPr lang="en-US" sz="1400" dirty="0" err="1" smtClean="0">
+                <a:solidFill>
+                  <a:srgbClr val="F7F5EF"/>
+                </a:solidFill>
+                <a:latin typeface="Courier New" pitchFamily="49" charset="0"/>
+                <a:ea typeface="Courier New" pitchFamily="49" charset="-122"/>
+                <a:cs typeface="Courier New" pitchFamily="49" charset="-120"/>
+              </a:rPr>
+              <a:t>v:string</a:t>
+            </a:r>
+            <a:r>
+              <a:rPr lang="en-US" sz="1400" dirty="0" smtClean="0">
+                <a:solidFill>
+                  <a:srgbClr val="F7F5EF"/>
+                </a:solidFill>
+                <a:latin typeface="Courier New" pitchFamily="49" charset="0"/>
+                <a:ea typeface="Courier New" pitchFamily="49" charset="-122"/>
+                <a:cs typeface="Courier New" pitchFamily="49" charset="-120"/>
+              </a:rPr>
+              <a:t>):</a:t>
+            </a:r>
+          </a:p>
+          <a:p>
+            <a:pPr marL="0" indent="0" algn="l">
+              <a:lnSpc>
+                <a:spcPts val="2030"/>
+              </a:lnSpc>
+              <a:buNone/>
+            </a:pPr>
+            <a:r>
+              <a:rPr lang="en-US" sz="1400" dirty="0">
+                <a:solidFill>
+                  <a:srgbClr val="F7F5EF"/>
+                </a:solidFill>
+                <a:latin typeface="Courier New" pitchFamily="49" charset="0"/>
+                <a:ea typeface="Courier New" pitchFamily="49" charset="-122"/>
+                <a:cs typeface="Courier New" pitchFamily="49" charset="-120"/>
+              </a:rPr>
+              <a:t>    return </a:t>
+            </a:r>
+            <a:r>
+              <a:rPr lang="en-US" sz="1400" dirty="0" err="1" smtClean="0">
+                <a:solidFill>
+                  <a:srgbClr val="F7F5EF"/>
+                </a:solidFill>
+                <a:latin typeface="Courier New" pitchFamily="49" charset="0"/>
+                <a:ea typeface="Courier New" pitchFamily="49" charset="-122"/>
+                <a:cs typeface="Courier New" pitchFamily="49" charset="-120"/>
+              </a:rPr>
+              <a:t>v.strip</a:t>
+            </a:r>
+            <a:r>
+              <a:rPr lang="en-US" sz="1400" dirty="0" smtClean="0">
+                <a:solidFill>
+                  <a:srgbClr val="F7F5EF"/>
+                </a:solidFill>
+                <a:latin typeface="Courier New" pitchFamily="49" charset="0"/>
+                <a:ea typeface="Courier New" pitchFamily="49" charset="-122"/>
+                <a:cs typeface="Courier New" pitchFamily="49" charset="-120"/>
+              </a:rPr>
+              <a:t>().lower() in {‘’, ‘</a:t>
+            </a:r>
+            <a:r>
+              <a:rPr lang="en-US" sz="1400" dirty="0" err="1" smtClean="0">
+                <a:solidFill>
+                  <a:srgbClr val="F7F5EF"/>
+                </a:solidFill>
+                <a:latin typeface="Courier New" pitchFamily="49" charset="0"/>
+                <a:ea typeface="Courier New" pitchFamily="49" charset="-122"/>
+                <a:cs typeface="Courier New" pitchFamily="49" charset="-120"/>
+              </a:rPr>
+              <a:t>na</a:t>
+            </a:r>
+            <a:r>
+              <a:rPr lang="en-US" sz="1400" dirty="0" smtClean="0">
+                <a:solidFill>
+                  <a:srgbClr val="F7F5EF"/>
+                </a:solidFill>
+                <a:latin typeface="Courier New" pitchFamily="49" charset="0"/>
+                <a:ea typeface="Courier New" pitchFamily="49" charset="-122"/>
+                <a:cs typeface="Courier New" pitchFamily="49" charset="-120"/>
+              </a:rPr>
+              <a:t>’, ‘N/A’, ‘n/a’, ‘null’, ‘none’, ‘nan’, ‘?’}</a:t>
+            </a:r>
+            <a:endParaRPr lang="en-US" sz="1400" dirty="0"/>
+          </a:p>
+        </p:txBody>
+      </p:sp>
     </p:spTree>
   </p:cSld>
   <p:clrMapOvr>
     <a:masterClrMapping/>
   </p:clrMapOvr>
+  <p:timing>
+    <p:tnLst>
+      <p:par>
+        <p:cTn id="1" dur="indefinite" restart="never" nodeType="tmRoot"/>
+      </p:par>
+    </p:tnLst>
+  </p:timing>
 </p:sld>
 </file>
 
@@ -4627,6 +4803,13 @@
   <p:clrMapOvr>
     <a:masterClrMapping/>
   </p:clrMapOvr>
+  <p:timing>
+    <p:tnLst>
+      <p:par>
+        <p:cTn id="1" dur="indefinite" restart="never" nodeType="tmRoot"/>
+      </p:par>
+    </p:tnLst>
+  </p:timing>
 </p:sld>
 </file>
 
@@ -4719,7 +4902,7 @@
         </p:nvGraphicFramePr>
         <p:xfrm>
           <a:off x="825500" y="1473200"/>
-          <a:ext cx="10553700" cy="2608659"/>
+          <a:ext cx="10553700" cy="2608662"/>
         </p:xfrm>
         <a:graphic>
           <a:graphicData uri="http://schemas.openxmlformats.org/drawingml/2006/table">
@@ -4729,21 +4912,21 @@
                 <a:gridCol w="3517900">
                   <a:extLst>
                     <a:ext uri="{9D8B030D-6E8A-4147-A177-3AD203B41FA5}">
-                      <a16:colId xmlns:a16="http://schemas.microsoft.com/office/drawing/2014/main" val="20000"/>
+                      <a16:colId xmlns="" xmlns:a16="http://schemas.microsoft.com/office/drawing/2014/main" val="20000"/>
                     </a:ext>
                   </a:extLst>
                 </a:gridCol>
                 <a:gridCol w="3517900">
                   <a:extLst>
                     <a:ext uri="{9D8B030D-6E8A-4147-A177-3AD203B41FA5}">
-                      <a16:colId xmlns:a16="http://schemas.microsoft.com/office/drawing/2014/main" val="20001"/>
+                      <a16:colId xmlns="" xmlns:a16="http://schemas.microsoft.com/office/drawing/2014/main" val="20001"/>
                     </a:ext>
                   </a:extLst>
                 </a:gridCol>
                 <a:gridCol w="3517900">
                   <a:extLst>
                     <a:ext uri="{9D8B030D-6E8A-4147-A177-3AD203B41FA5}">
-                      <a16:colId xmlns:a16="http://schemas.microsoft.com/office/drawing/2014/main" val="20002"/>
+                      <a16:colId xmlns="" xmlns:a16="http://schemas.microsoft.com/office/drawing/2014/main" val="20002"/>
                     </a:ext>
                   </a:extLst>
                 </a:gridCol>
@@ -4964,7 +5147,7 @@
                 </a:tc>
                 <a:extLst>
                   <a:ext uri="{0D108BD9-81ED-4DB2-BD59-A6C34878D82A}">
-                    <a16:rowId xmlns:a16="http://schemas.microsoft.com/office/drawing/2014/main" val="10000"/>
+                    <a16:rowId xmlns="" xmlns:a16="http://schemas.microsoft.com/office/drawing/2014/main" val="10000"/>
                   </a:ext>
                 </a:extLst>
               </a:tr>
@@ -5175,7 +5358,7 @@
                 </a:tc>
                 <a:extLst>
                   <a:ext uri="{0D108BD9-81ED-4DB2-BD59-A6C34878D82A}">
-                    <a16:rowId xmlns:a16="http://schemas.microsoft.com/office/drawing/2014/main" val="10001"/>
+                    <a16:rowId xmlns="" xmlns:a16="http://schemas.microsoft.com/office/drawing/2014/main" val="10001"/>
                   </a:ext>
                 </a:extLst>
               </a:tr>
@@ -5386,7 +5569,7 @@
                 </a:tc>
                 <a:extLst>
                   <a:ext uri="{0D108BD9-81ED-4DB2-BD59-A6C34878D82A}">
-                    <a16:rowId xmlns:a16="http://schemas.microsoft.com/office/drawing/2014/main" val="10002"/>
+                    <a16:rowId xmlns="" xmlns:a16="http://schemas.microsoft.com/office/drawing/2014/main" val="10002"/>
                   </a:ext>
                 </a:extLst>
               </a:tr>
@@ -5597,7 +5780,7 @@
                 </a:tc>
                 <a:extLst>
                   <a:ext uri="{0D108BD9-81ED-4DB2-BD59-A6C34878D82A}">
-                    <a16:rowId xmlns:a16="http://schemas.microsoft.com/office/drawing/2014/main" val="10003"/>
+                    <a16:rowId xmlns="" xmlns:a16="http://schemas.microsoft.com/office/drawing/2014/main" val="10003"/>
                   </a:ext>
                 </a:extLst>
               </a:tr>
@@ -5808,7 +5991,7 @@
                 </a:tc>
                 <a:extLst>
                   <a:ext uri="{0D108BD9-81ED-4DB2-BD59-A6C34878D82A}">
-                    <a16:rowId xmlns:a16="http://schemas.microsoft.com/office/drawing/2014/main" val="10004"/>
+                    <a16:rowId xmlns="" xmlns:a16="http://schemas.microsoft.com/office/drawing/2014/main" val="10004"/>
                   </a:ext>
                 </a:extLst>
               </a:tr>
@@ -6019,7 +6202,7 @@
                 </a:tc>
                 <a:extLst>
                   <a:ext uri="{0D108BD9-81ED-4DB2-BD59-A6C34878D82A}">
-                    <a16:rowId xmlns:a16="http://schemas.microsoft.com/office/drawing/2014/main" val="10005"/>
+                    <a16:rowId xmlns="" xmlns:a16="http://schemas.microsoft.com/office/drawing/2014/main" val="10005"/>
                   </a:ext>
                 </a:extLst>
               </a:tr>
@@ -6230,7 +6413,7 @@
                 </a:tc>
                 <a:extLst>
                   <a:ext uri="{0D108BD9-81ED-4DB2-BD59-A6C34878D82A}">
-                    <a16:rowId xmlns:a16="http://schemas.microsoft.com/office/drawing/2014/main" val="10006"/>
+                    <a16:rowId xmlns="" xmlns:a16="http://schemas.microsoft.com/office/drawing/2014/main" val="10006"/>
                   </a:ext>
                 </a:extLst>
               </a:tr>
@@ -6287,6 +6470,13 @@
   <p:clrMapOvr>
     <a:masterClrMapping/>
   </p:clrMapOvr>
+  <p:timing>
+    <p:tnLst>
+      <p:par>
+        <p:cTn id="1" dur="indefinite" restart="never" nodeType="tmRoot"/>
+      </p:par>
+    </p:tnLst>
+  </p:timing>
 </p:sld>
 </file>
 
@@ -6935,6 +7125,416 @@
   <p:clrMapOvr>
     <a:masterClrMapping/>
   </p:clrMapOvr>
+  <p:timing>
+    <p:tnLst>
+      <p:par>
+        <p:cTn id="1" dur="indefinite" restart="never" nodeType="tmRoot">
+          <p:childTnLst>
+            <p:seq concurrent="1" nextAc="seek">
+              <p:cTn id="2" dur="indefinite" nodeType="mainSeq">
+                <p:childTnLst>
+                  <p:par>
+                    <p:cTn id="3" fill="hold">
+                      <p:stCondLst>
+                        <p:cond delay="indefinite"/>
+                      </p:stCondLst>
+                      <p:childTnLst>
+                        <p:par>
+                          <p:cTn id="4" fill="hold">
+                            <p:stCondLst>
+                              <p:cond delay="0"/>
+                            </p:stCondLst>
+                            <p:childTnLst>
+                              <p:par>
+                                <p:cTn id="5" presetID="16" presetClass="entr" presetSubtype="21" fill="hold" grpId="0" nodeType="clickEffect">
+                                  <p:stCondLst>
+                                    <p:cond delay="0"/>
+                                  </p:stCondLst>
+                                  <p:childTnLst>
+                                    <p:set>
+                                      <p:cBhvr>
+                                        <p:cTn id="6" dur="1" fill="hold">
+                                          <p:stCondLst>
+                                            <p:cond delay="0"/>
+                                          </p:stCondLst>
+                                        </p:cTn>
+                                        <p:tgtEl>
+                                          <p:spTgt spid="4"/>
+                                        </p:tgtEl>
+                                        <p:attrNameLst>
+                                          <p:attrName>style.visibility</p:attrName>
+                                        </p:attrNameLst>
+                                      </p:cBhvr>
+                                      <p:to>
+                                        <p:strVal val="visible"/>
+                                      </p:to>
+                                    </p:set>
+                                    <p:animEffect transition="in" filter="barn(inVertical)">
+                                      <p:cBhvr>
+                                        <p:cTn id="7" dur="500"/>
+                                        <p:tgtEl>
+                                          <p:spTgt spid="4"/>
+                                        </p:tgtEl>
+                                      </p:cBhvr>
+                                    </p:animEffect>
+                                  </p:childTnLst>
+                                </p:cTn>
+                              </p:par>
+                              <p:par>
+                                <p:cTn id="8" presetID="16" presetClass="entr" presetSubtype="21" fill="hold" grpId="0" nodeType="withEffect">
+                                  <p:stCondLst>
+                                    <p:cond delay="0"/>
+                                  </p:stCondLst>
+                                  <p:childTnLst>
+                                    <p:set>
+                                      <p:cBhvr>
+                                        <p:cTn id="9" dur="1" fill="hold">
+                                          <p:stCondLst>
+                                            <p:cond delay="0"/>
+                                          </p:stCondLst>
+                                        </p:cTn>
+                                        <p:tgtEl>
+                                          <p:spTgt spid="5"/>
+                                        </p:tgtEl>
+                                        <p:attrNameLst>
+                                          <p:attrName>style.visibility</p:attrName>
+                                        </p:attrNameLst>
+                                      </p:cBhvr>
+                                      <p:to>
+                                        <p:strVal val="visible"/>
+                                      </p:to>
+                                    </p:set>
+                                    <p:animEffect transition="in" filter="barn(inVertical)">
+                                      <p:cBhvr>
+                                        <p:cTn id="10" dur="500"/>
+                                        <p:tgtEl>
+                                          <p:spTgt spid="5"/>
+                                        </p:tgtEl>
+                                      </p:cBhvr>
+                                    </p:animEffect>
+                                  </p:childTnLst>
+                                </p:cTn>
+                              </p:par>
+                              <p:par>
+                                <p:cTn id="11" presetID="16" presetClass="entr" presetSubtype="21" fill="hold" grpId="0" nodeType="withEffect">
+                                  <p:stCondLst>
+                                    <p:cond delay="0"/>
+                                  </p:stCondLst>
+                                  <p:childTnLst>
+                                    <p:set>
+                                      <p:cBhvr>
+                                        <p:cTn id="12" dur="1" fill="hold">
+                                          <p:stCondLst>
+                                            <p:cond delay="0"/>
+                                          </p:stCondLst>
+                                        </p:cTn>
+                                        <p:tgtEl>
+                                          <p:spTgt spid="6"/>
+                                        </p:tgtEl>
+                                        <p:attrNameLst>
+                                          <p:attrName>style.visibility</p:attrName>
+                                        </p:attrNameLst>
+                                      </p:cBhvr>
+                                      <p:to>
+                                        <p:strVal val="visible"/>
+                                      </p:to>
+                                    </p:set>
+                                    <p:animEffect transition="in" filter="barn(inVertical)">
+                                      <p:cBhvr>
+                                        <p:cTn id="13" dur="500"/>
+                                        <p:tgtEl>
+                                          <p:spTgt spid="6"/>
+                                        </p:tgtEl>
+                                      </p:cBhvr>
+                                    </p:animEffect>
+                                  </p:childTnLst>
+                                </p:cTn>
+                              </p:par>
+                            </p:childTnLst>
+                          </p:cTn>
+                        </p:par>
+                      </p:childTnLst>
+                    </p:cTn>
+                  </p:par>
+                  <p:par>
+                    <p:cTn id="14" fill="hold">
+                      <p:stCondLst>
+                        <p:cond delay="indefinite"/>
+                      </p:stCondLst>
+                      <p:childTnLst>
+                        <p:par>
+                          <p:cTn id="15" fill="hold">
+                            <p:stCondLst>
+                              <p:cond delay="0"/>
+                            </p:stCondLst>
+                            <p:childTnLst>
+                              <p:par>
+                                <p:cTn id="16" presetID="16" presetClass="entr" presetSubtype="21" fill="hold" grpId="0" nodeType="clickEffect">
+                                  <p:stCondLst>
+                                    <p:cond delay="0"/>
+                                  </p:stCondLst>
+                                  <p:childTnLst>
+                                    <p:set>
+                                      <p:cBhvr>
+                                        <p:cTn id="17" dur="1" fill="hold">
+                                          <p:stCondLst>
+                                            <p:cond delay="0"/>
+                                          </p:stCondLst>
+                                        </p:cTn>
+                                        <p:tgtEl>
+                                          <p:spTgt spid="7"/>
+                                        </p:tgtEl>
+                                        <p:attrNameLst>
+                                          <p:attrName>style.visibility</p:attrName>
+                                        </p:attrNameLst>
+                                      </p:cBhvr>
+                                      <p:to>
+                                        <p:strVal val="visible"/>
+                                      </p:to>
+                                    </p:set>
+                                    <p:animEffect transition="in" filter="barn(inVertical)">
+                                      <p:cBhvr>
+                                        <p:cTn id="18" dur="500"/>
+                                        <p:tgtEl>
+                                          <p:spTgt spid="7"/>
+                                        </p:tgtEl>
+                                      </p:cBhvr>
+                                    </p:animEffect>
+                                  </p:childTnLst>
+                                </p:cTn>
+                              </p:par>
+                              <p:par>
+                                <p:cTn id="19" presetID="16" presetClass="entr" presetSubtype="21" fill="hold" grpId="0" nodeType="withEffect">
+                                  <p:stCondLst>
+                                    <p:cond delay="0"/>
+                                  </p:stCondLst>
+                                  <p:childTnLst>
+                                    <p:set>
+                                      <p:cBhvr>
+                                        <p:cTn id="20" dur="1" fill="hold">
+                                          <p:stCondLst>
+                                            <p:cond delay="0"/>
+                                          </p:stCondLst>
+                                        </p:cTn>
+                                        <p:tgtEl>
+                                          <p:spTgt spid="8"/>
+                                        </p:tgtEl>
+                                        <p:attrNameLst>
+                                          <p:attrName>style.visibility</p:attrName>
+                                        </p:attrNameLst>
+                                      </p:cBhvr>
+                                      <p:to>
+                                        <p:strVal val="visible"/>
+                                      </p:to>
+                                    </p:set>
+                                    <p:animEffect transition="in" filter="barn(inVertical)">
+                                      <p:cBhvr>
+                                        <p:cTn id="21" dur="500"/>
+                                        <p:tgtEl>
+                                          <p:spTgt spid="8"/>
+                                        </p:tgtEl>
+                                      </p:cBhvr>
+                                    </p:animEffect>
+                                  </p:childTnLst>
+                                </p:cTn>
+                              </p:par>
+                              <p:par>
+                                <p:cTn id="22" presetID="16" presetClass="entr" presetSubtype="21" fill="hold" grpId="0" nodeType="withEffect">
+                                  <p:stCondLst>
+                                    <p:cond delay="0"/>
+                                  </p:stCondLst>
+                                  <p:childTnLst>
+                                    <p:set>
+                                      <p:cBhvr>
+                                        <p:cTn id="23" dur="1" fill="hold">
+                                          <p:stCondLst>
+                                            <p:cond delay="0"/>
+                                          </p:stCondLst>
+                                        </p:cTn>
+                                        <p:tgtEl>
+                                          <p:spTgt spid="9"/>
+                                        </p:tgtEl>
+                                        <p:attrNameLst>
+                                          <p:attrName>style.visibility</p:attrName>
+                                        </p:attrNameLst>
+                                      </p:cBhvr>
+                                      <p:to>
+                                        <p:strVal val="visible"/>
+                                      </p:to>
+                                    </p:set>
+                                    <p:animEffect transition="in" filter="barn(inVertical)">
+                                      <p:cBhvr>
+                                        <p:cTn id="24" dur="500"/>
+                                        <p:tgtEl>
+                                          <p:spTgt spid="9"/>
+                                        </p:tgtEl>
+                                      </p:cBhvr>
+                                    </p:animEffect>
+                                  </p:childTnLst>
+                                </p:cTn>
+                              </p:par>
+                            </p:childTnLst>
+                          </p:cTn>
+                        </p:par>
+                      </p:childTnLst>
+                    </p:cTn>
+                  </p:par>
+                  <p:par>
+                    <p:cTn id="25" fill="hold">
+                      <p:stCondLst>
+                        <p:cond delay="indefinite"/>
+                      </p:stCondLst>
+                      <p:childTnLst>
+                        <p:par>
+                          <p:cTn id="26" fill="hold">
+                            <p:stCondLst>
+                              <p:cond delay="0"/>
+                            </p:stCondLst>
+                            <p:childTnLst>
+                              <p:par>
+                                <p:cTn id="27" presetID="16" presetClass="entr" presetSubtype="21" fill="hold" grpId="0" nodeType="clickEffect">
+                                  <p:stCondLst>
+                                    <p:cond delay="0"/>
+                                  </p:stCondLst>
+                                  <p:childTnLst>
+                                    <p:set>
+                                      <p:cBhvr>
+                                        <p:cTn id="28" dur="1" fill="hold">
+                                          <p:stCondLst>
+                                            <p:cond delay="0"/>
+                                          </p:stCondLst>
+                                        </p:cTn>
+                                        <p:tgtEl>
+                                          <p:spTgt spid="10"/>
+                                        </p:tgtEl>
+                                        <p:attrNameLst>
+                                          <p:attrName>style.visibility</p:attrName>
+                                        </p:attrNameLst>
+                                      </p:cBhvr>
+                                      <p:to>
+                                        <p:strVal val="visible"/>
+                                      </p:to>
+                                    </p:set>
+                                    <p:animEffect transition="in" filter="barn(inVertical)">
+                                      <p:cBhvr>
+                                        <p:cTn id="29" dur="500"/>
+                                        <p:tgtEl>
+                                          <p:spTgt spid="10"/>
+                                        </p:tgtEl>
+                                      </p:cBhvr>
+                                    </p:animEffect>
+                                  </p:childTnLst>
+                                </p:cTn>
+                              </p:par>
+                              <p:par>
+                                <p:cTn id="30" presetID="16" presetClass="entr" presetSubtype="21" fill="hold" grpId="0" nodeType="withEffect">
+                                  <p:stCondLst>
+                                    <p:cond delay="0"/>
+                                  </p:stCondLst>
+                                  <p:childTnLst>
+                                    <p:set>
+                                      <p:cBhvr>
+                                        <p:cTn id="31" dur="1" fill="hold">
+                                          <p:stCondLst>
+                                            <p:cond delay="0"/>
+                                          </p:stCondLst>
+                                        </p:cTn>
+                                        <p:tgtEl>
+                                          <p:spTgt spid="11"/>
+                                        </p:tgtEl>
+                                        <p:attrNameLst>
+                                          <p:attrName>style.visibility</p:attrName>
+                                        </p:attrNameLst>
+                                      </p:cBhvr>
+                                      <p:to>
+                                        <p:strVal val="visible"/>
+                                      </p:to>
+                                    </p:set>
+                                    <p:animEffect transition="in" filter="barn(inVertical)">
+                                      <p:cBhvr>
+                                        <p:cTn id="32" dur="500"/>
+                                        <p:tgtEl>
+                                          <p:spTgt spid="11"/>
+                                        </p:tgtEl>
+                                      </p:cBhvr>
+                                    </p:animEffect>
+                                  </p:childTnLst>
+                                </p:cTn>
+                              </p:par>
+                              <p:par>
+                                <p:cTn id="33" presetID="16" presetClass="entr" presetSubtype="21" fill="hold" grpId="0" nodeType="withEffect">
+                                  <p:stCondLst>
+                                    <p:cond delay="0"/>
+                                  </p:stCondLst>
+                                  <p:childTnLst>
+                                    <p:set>
+                                      <p:cBhvr>
+                                        <p:cTn id="34" dur="1" fill="hold">
+                                          <p:stCondLst>
+                                            <p:cond delay="0"/>
+                                          </p:stCondLst>
+                                        </p:cTn>
+                                        <p:tgtEl>
+                                          <p:spTgt spid="12"/>
+                                        </p:tgtEl>
+                                        <p:attrNameLst>
+                                          <p:attrName>style.visibility</p:attrName>
+                                        </p:attrNameLst>
+                                      </p:cBhvr>
+                                      <p:to>
+                                        <p:strVal val="visible"/>
+                                      </p:to>
+                                    </p:set>
+                                    <p:animEffect transition="in" filter="barn(inVertical)">
+                                      <p:cBhvr>
+                                        <p:cTn id="35" dur="500"/>
+                                        <p:tgtEl>
+                                          <p:spTgt spid="12"/>
+                                        </p:tgtEl>
+                                      </p:cBhvr>
+                                    </p:animEffect>
+                                  </p:childTnLst>
+                                </p:cTn>
+                              </p:par>
+                            </p:childTnLst>
+                          </p:cTn>
+                        </p:par>
+                      </p:childTnLst>
+                    </p:cTn>
+                  </p:par>
+                </p:childTnLst>
+              </p:cTn>
+              <p:prevCondLst>
+                <p:cond evt="onPrev" delay="0">
+                  <p:tgtEl>
+                    <p:sldTgt/>
+                  </p:tgtEl>
+                </p:cond>
+              </p:prevCondLst>
+              <p:nextCondLst>
+                <p:cond evt="onNext" delay="0">
+                  <p:tgtEl>
+                    <p:sldTgt/>
+                  </p:tgtEl>
+                </p:cond>
+              </p:nextCondLst>
+            </p:seq>
+          </p:childTnLst>
+        </p:cTn>
+      </p:par>
+    </p:tnLst>
+    <p:bldLst>
+      <p:bldP spid="4" grpId="0" animBg="1"/>
+      <p:bldP spid="5" grpId="0" animBg="1"/>
+      <p:bldP spid="6" grpId="0" animBg="1"/>
+      <p:bldP spid="7" grpId="0" animBg="1"/>
+      <p:bldP spid="8" grpId="0" animBg="1"/>
+      <p:bldP spid="9" grpId="0" animBg="1"/>
+      <p:bldP spid="10" grpId="0" animBg="1"/>
+      <p:bldP spid="11" grpId="0" animBg="1"/>
+      <p:bldP spid="12" grpId="0" animBg="1"/>
+    </p:bldLst>
+  </p:timing>
 </p:sld>
 </file>
 
@@ -7019,7 +7619,7 @@
         </p:nvSpPr>
         <p:spPr>
           <a:xfrm>
-            <a:off x="812800" y="1460500"/>
+            <a:off x="812800" y="1431925"/>
             <a:ext cx="10566400" cy="2395141"/>
           </a:xfrm>
           <a:prstGeom prst="roundRect">
@@ -7034,7 +7634,7 @@
         </p:spPr>
         <p:txBody>
           <a:bodyPr wrap="square" lIns="173442" tIns="173442" rIns="0" bIns="148042" rtlCol="0" anchor="t">
-            <a:normAutofit/>
+            <a:noAutofit/>
           </a:bodyPr>
           <a:lstStyle/>
           <a:p>
@@ -7045,17 +7645,20 @@
               <a:buNone/>
             </a:pPr>
             <a:r>
-              <a:rPr lang="en-US" sz="1350" dirty="0">
+              <a:rPr lang="en-US" sz="1400" dirty="0">
                 <a:solidFill>
                   <a:srgbClr val="F7F5EF"/>
                 </a:solidFill>
-                <a:latin typeface="Courier New" pitchFamily="49" charset="0"/>
-                <a:ea typeface="Courier New" pitchFamily="49" charset="-122"/>
-                <a:cs typeface="Courier New" pitchFamily="49" charset="-120"/>
+                <a:latin typeface="Courier New" panose="02070309020205020404" pitchFamily="49" charset="0"/>
+                <a:ea typeface="Courier New" pitchFamily="49" charset="-122"/>
+                <a:cs typeface="Courier New" panose="02070309020205020404" pitchFamily="49" charset="0"/>
               </a:rPr>
               <a:t>import csv</a:t>
             </a:r>
-            <a:endParaRPr lang="en-US" sz="1350" dirty="0"/>
+            <a:endParaRPr lang="en-US" sz="1400" dirty="0">
+              <a:latin typeface="Courier New" panose="02070309020205020404" pitchFamily="49" charset="0"/>
+              <a:cs typeface="Courier New" panose="02070309020205020404" pitchFamily="49" charset="0"/>
+            </a:endParaRPr>
           </a:p>
           <a:p>
             <a:pPr marL="0" indent="0" algn="l">
@@ -7065,17 +7668,31 @@
               <a:buNone/>
             </a:pPr>
             <a:r>
-              <a:rPr lang="en-US" sz="1350" dirty="0">
+              <a:rPr lang="en-US" sz="1400" dirty="0">
                 <a:solidFill>
                   <a:srgbClr val="F7F5EF"/>
                 </a:solidFill>
                 <a:latin typeface="Courier New" pitchFamily="49" charset="0"/>
                 <a:ea typeface="Courier New" pitchFamily="49" charset="-122"/>
-                <a:cs typeface="Courier New" pitchFamily="49" charset="-120"/>
-              </a:rPr>
-              <a:t>from pathlib import Path</a:t>
-            </a:r>
-            <a:endParaRPr lang="en-US" sz="1350" dirty="0"/>
+                <a:cs typeface="Courier New" panose="02070309020205020404" pitchFamily="49" charset="0"/>
+              </a:rPr>
+              <a:t>from pathlib import </a:t>
+            </a:r>
+            <a:r>
+              <a:rPr lang="en-US" sz="1400" dirty="0" smtClean="0">
+                <a:solidFill>
+                  <a:srgbClr val="F7F5EF"/>
+                </a:solidFill>
+                <a:latin typeface="Courier New" pitchFamily="49" charset="0"/>
+                <a:ea typeface="Courier New" pitchFamily="49" charset="-122"/>
+                <a:cs typeface="Courier New" panose="02070309020205020404" pitchFamily="49" charset="0"/>
+              </a:rPr>
+              <a:t>Path</a:t>
+            </a:r>
+            <a:endParaRPr lang="en-US" sz="1400" dirty="0">
+              <a:latin typeface="Courier New" panose="02070309020205020404" pitchFamily="49" charset="0"/>
+              <a:cs typeface="Courier New" panose="02070309020205020404" pitchFamily="49" charset="0"/>
+            </a:endParaRPr>
           </a:p>
           <a:p>
             <a:pPr marL="0" indent="0" algn="l">
@@ -7084,7 +7701,10 @@
               </a:lnSpc>
               <a:buNone/>
             </a:pPr>
-            <a:endParaRPr lang="en-US" sz="1350" dirty="0"/>
+            <a:endParaRPr lang="en-US" sz="1400" dirty="0">
+              <a:latin typeface="Courier New" panose="02070309020205020404" pitchFamily="49" charset="0"/>
+              <a:cs typeface="Courier New" panose="02070309020205020404" pitchFamily="49" charset="0"/>
+            </a:endParaRPr>
           </a:p>
           <a:p>
             <a:pPr marL="0" indent="0" algn="l">
@@ -7094,17 +7714,31 @@
               <a:buNone/>
             </a:pPr>
             <a:r>
-              <a:rPr lang="en-US" sz="1350" dirty="0">
+              <a:rPr lang="en-US" sz="1400" dirty="0">
                 <a:solidFill>
                   <a:srgbClr val="F7F5EF"/>
                 </a:solidFill>
                 <a:latin typeface="Courier New" pitchFamily="49" charset="0"/>
                 <a:ea typeface="Courier New" pitchFamily="49" charset="-122"/>
-                <a:cs typeface="Courier New" pitchFamily="49" charset="-120"/>
-              </a:rPr>
-              <a:t>path = Path('orders.csv')</a:t>
-            </a:r>
-            <a:endParaRPr lang="en-US" sz="1350" dirty="0"/>
+                <a:cs typeface="Courier New" panose="02070309020205020404" pitchFamily="49" charset="0"/>
+              </a:rPr>
+              <a:t>path = Path('orders.csv</a:t>
+            </a:r>
+            <a:r>
+              <a:rPr lang="en-US" sz="1400" dirty="0" smtClean="0">
+                <a:solidFill>
+                  <a:srgbClr val="F7F5EF"/>
+                </a:solidFill>
+                <a:latin typeface="Courier New" pitchFamily="49" charset="0"/>
+                <a:ea typeface="Courier New" pitchFamily="49" charset="-122"/>
+                <a:cs typeface="Courier New" panose="02070309020205020404" pitchFamily="49" charset="0"/>
+              </a:rPr>
+              <a:t>')</a:t>
+            </a:r>
+            <a:endParaRPr lang="en-US" sz="1400" dirty="0">
+              <a:latin typeface="Courier New" panose="02070309020205020404" pitchFamily="49" charset="0"/>
+              <a:cs typeface="Courier New" panose="02070309020205020404" pitchFamily="49" charset="0"/>
+            </a:endParaRPr>
           </a:p>
           <a:p>
             <a:pPr marL="0" indent="0" algn="l">
@@ -7114,17 +7748,20 @@
               <a:buNone/>
             </a:pPr>
             <a:r>
-              <a:rPr lang="en-US" sz="1350" dirty="0">
+              <a:rPr lang="en-US" sz="1400" dirty="0">
                 <a:solidFill>
                   <a:srgbClr val="F7F5EF"/>
                 </a:solidFill>
                 <a:latin typeface="Courier New" pitchFamily="49" charset="0"/>
                 <a:ea typeface="Courier New" pitchFamily="49" charset="-122"/>
-                <a:cs typeface="Courier New" pitchFamily="49" charset="-120"/>
+                <a:cs typeface="Courier New" panose="02070309020205020404" pitchFamily="49" charset="0"/>
               </a:rPr>
               <a:t>with path.open(newline='', encoding='utf-8') as f:</a:t>
             </a:r>
-            <a:endParaRPr lang="en-US" sz="1350" dirty="0"/>
+            <a:endParaRPr lang="en-US" sz="1400" dirty="0">
+              <a:latin typeface="Courier New" panose="02070309020205020404" pitchFamily="49" charset="0"/>
+              <a:cs typeface="Courier New" panose="02070309020205020404" pitchFamily="49" charset="0"/>
+            </a:endParaRPr>
           </a:p>
           <a:p>
             <a:pPr marL="0" indent="0" algn="l">
@@ -7134,17 +7771,20 @@
               <a:buNone/>
             </a:pPr>
             <a:r>
-              <a:rPr lang="en-US" sz="1350" dirty="0">
+              <a:rPr lang="en-US" sz="1400" dirty="0">
                 <a:solidFill>
                   <a:srgbClr val="F7F5EF"/>
                 </a:solidFill>
                 <a:latin typeface="Courier New" pitchFamily="49" charset="0"/>
                 <a:ea typeface="Courier New" pitchFamily="49" charset="-122"/>
-                <a:cs typeface="Courier New" pitchFamily="49" charset="-120"/>
+                <a:cs typeface="Courier New" panose="02070309020205020404" pitchFamily="49" charset="0"/>
               </a:rPr>
               <a:t>    rows = list(csv.DictReader(f))</a:t>
             </a:r>
-            <a:endParaRPr lang="en-US" sz="1350" dirty="0"/>
+            <a:endParaRPr lang="en-US" sz="1400" dirty="0">
+              <a:latin typeface="Courier New" panose="02070309020205020404" pitchFamily="49" charset="0"/>
+              <a:cs typeface="Courier New" panose="02070309020205020404" pitchFamily="49" charset="0"/>
+            </a:endParaRPr>
           </a:p>
           <a:p>
             <a:pPr marL="0" indent="0" algn="l">
@@ -7154,17 +7794,20 @@
               <a:buNone/>
             </a:pPr>
             <a:r>
-              <a:rPr lang="en-US" sz="1350" dirty="0">
+              <a:rPr lang="en-US" sz="1400" dirty="0">
                 <a:solidFill>
                   <a:srgbClr val="F7F5EF"/>
                 </a:solidFill>
                 <a:latin typeface="Courier New" pitchFamily="49" charset="0"/>
                 <a:ea typeface="Courier New" pitchFamily="49" charset="-122"/>
-                <a:cs typeface="Courier New" pitchFamily="49" charset="-120"/>
+                <a:cs typeface="Courier New" panose="02070309020205020404" pitchFamily="49" charset="0"/>
               </a:rPr>
               <a:t>print(len(rows), list(rows[0]))</a:t>
             </a:r>
-            <a:endParaRPr lang="en-US" sz="1350" dirty="0"/>
+            <a:endParaRPr lang="en-US" sz="1400" dirty="0">
+              <a:latin typeface="Courier New" panose="02070309020205020404" pitchFamily="49" charset="0"/>
+              <a:cs typeface="Courier New" panose="02070309020205020404" pitchFamily="49" charset="0"/>
+            </a:endParaRPr>
           </a:p>
           <a:p>
             <a:pPr marL="0" indent="0" algn="l">
@@ -7174,17 +7817,20 @@
               <a:buNone/>
             </a:pPr>
             <a:r>
-              <a:rPr lang="en-US" sz="1350" dirty="0">
+              <a:rPr lang="en-US" sz="1400" dirty="0">
                 <a:solidFill>
                   <a:srgbClr val="F7F5EF"/>
                 </a:solidFill>
                 <a:latin typeface="Courier New" pitchFamily="49" charset="0"/>
                 <a:ea typeface="Courier New" pitchFamily="49" charset="-122"/>
-                <a:cs typeface="Courier New" pitchFamily="49" charset="-120"/>
+                <a:cs typeface="Courier New" panose="02070309020205020404" pitchFamily="49" charset="0"/>
               </a:rPr>
               <a:t>print(repr(rows[0]['unit_price']))   # '3450': text</a:t>
             </a:r>
-            <a:endParaRPr lang="en-US" sz="1350" dirty="0"/>
+            <a:endParaRPr lang="en-US" sz="1400" dirty="0">
+              <a:latin typeface="Courier New" panose="02070309020205020404" pitchFamily="49" charset="0"/>
+              <a:cs typeface="Courier New" panose="02070309020205020404" pitchFamily="49" charset="0"/>
+            </a:endParaRPr>
           </a:p>
         </p:txBody>
       </p:sp>
@@ -7281,6 +7927,13 @@
   <p:clrMapOvr>
     <a:masterClrMapping/>
   </p:clrMapOvr>
+  <p:timing>
+    <p:tnLst>
+      <p:par>
+        <p:cTn id="1" dur="indefinite" restart="never" nodeType="tmRoot"/>
+      </p:par>
+    </p:tnLst>
+  </p:timing>
 </p:sld>
 </file>
 
@@ -7618,6 +8271,13 @@
   <p:clrMapOvr>
     <a:masterClrMapping/>
   </p:clrMapOvr>
+  <p:timing>
+    <p:tnLst>
+      <p:par>
+        <p:cTn id="1" dur="indefinite" restart="never" nodeType="tmRoot"/>
+      </p:par>
+    </p:tnLst>
+  </p:timing>
 </p:sld>
 </file>
 
@@ -7987,6 +8647,92 @@
   <p:clrMapOvr>
     <a:masterClrMapping/>
   </p:clrMapOvr>
+  <p:timing>
+    <p:tnLst>
+      <p:par>
+        <p:cTn id="1" dur="indefinite" restart="never" nodeType="tmRoot">
+          <p:childTnLst>
+            <p:seq concurrent="1" nextAc="seek">
+              <p:cTn id="2" dur="indefinite" nodeType="mainSeq">
+                <p:childTnLst>
+                  <p:par>
+                    <p:cTn id="3" fill="hold">
+                      <p:stCondLst>
+                        <p:cond delay="indefinite"/>
+                      </p:stCondLst>
+                      <p:childTnLst>
+                        <p:par>
+                          <p:cTn id="4" fill="hold">
+                            <p:stCondLst>
+                              <p:cond delay="0"/>
+                            </p:stCondLst>
+                            <p:childTnLst>
+                              <p:par>
+                                <p:cTn id="5" presetID="16" presetClass="entr" presetSubtype="21" fill="hold" grpId="0" nodeType="clickEffect">
+                                  <p:stCondLst>
+                                    <p:cond delay="0"/>
+                                  </p:stCondLst>
+                                  <p:childTnLst>
+                                    <p:set>
+                                      <p:cBhvr>
+                                        <p:cTn id="6" dur="1" fill="hold">
+                                          <p:stCondLst>
+                                            <p:cond delay="0"/>
+                                          </p:stCondLst>
+                                        </p:cTn>
+                                        <p:tgtEl>
+                                          <p:spTgt spid="6"/>
+                                        </p:tgtEl>
+                                        <p:attrNameLst>
+                                          <p:attrName>style.visibility</p:attrName>
+                                        </p:attrNameLst>
+                                      </p:cBhvr>
+                                      <p:to>
+                                        <p:strVal val="visible"/>
+                                      </p:to>
+                                    </p:set>
+                                    <p:animEffect transition="in" filter="barn(inVertical)">
+                                      <p:cBhvr>
+                                        <p:cTn id="7" dur="500"/>
+                                        <p:tgtEl>
+                                          <p:spTgt spid="6"/>
+                                        </p:tgtEl>
+                                      </p:cBhvr>
+                                    </p:animEffect>
+                                  </p:childTnLst>
+                                </p:cTn>
+                              </p:par>
+                            </p:childTnLst>
+                          </p:cTn>
+                        </p:par>
+                      </p:childTnLst>
+                    </p:cTn>
+                  </p:par>
+                </p:childTnLst>
+              </p:cTn>
+              <p:prevCondLst>
+                <p:cond evt="onPrev" delay="0">
+                  <p:tgtEl>
+                    <p:sldTgt/>
+                  </p:tgtEl>
+                </p:cond>
+              </p:prevCondLst>
+              <p:nextCondLst>
+                <p:cond evt="onNext" delay="0">
+                  <p:tgtEl>
+                    <p:sldTgt/>
+                  </p:tgtEl>
+                </p:cond>
+              </p:nextCondLst>
+            </p:seq>
+          </p:childTnLst>
+        </p:cTn>
+      </p:par>
+    </p:tnLst>
+    <p:bldLst>
+      <p:bldP spid="6" grpId="0" animBg="1"/>
+    </p:bldLst>
+  </p:timing>
 </p:sld>
 </file>
 
@@ -8308,6 +9054,92 @@
   <p:clrMapOvr>
     <a:masterClrMapping/>
   </p:clrMapOvr>
+  <p:timing>
+    <p:tnLst>
+      <p:par>
+        <p:cTn id="1" dur="indefinite" restart="never" nodeType="tmRoot">
+          <p:childTnLst>
+            <p:seq concurrent="1" nextAc="seek">
+              <p:cTn id="2" dur="indefinite" nodeType="mainSeq">
+                <p:childTnLst>
+                  <p:par>
+                    <p:cTn id="3" fill="hold">
+                      <p:stCondLst>
+                        <p:cond delay="indefinite"/>
+                      </p:stCondLst>
+                      <p:childTnLst>
+                        <p:par>
+                          <p:cTn id="4" fill="hold">
+                            <p:stCondLst>
+                              <p:cond delay="0"/>
+                            </p:stCondLst>
+                            <p:childTnLst>
+                              <p:par>
+                                <p:cTn id="5" presetID="16" presetClass="entr" presetSubtype="21" fill="hold" grpId="0" nodeType="clickEffect">
+                                  <p:stCondLst>
+                                    <p:cond delay="0"/>
+                                  </p:stCondLst>
+                                  <p:childTnLst>
+                                    <p:set>
+                                      <p:cBhvr>
+                                        <p:cTn id="6" dur="1" fill="hold">
+                                          <p:stCondLst>
+                                            <p:cond delay="0"/>
+                                          </p:stCondLst>
+                                        </p:cTn>
+                                        <p:tgtEl>
+                                          <p:spTgt spid="4"/>
+                                        </p:tgtEl>
+                                        <p:attrNameLst>
+                                          <p:attrName>style.visibility</p:attrName>
+                                        </p:attrNameLst>
+                                      </p:cBhvr>
+                                      <p:to>
+                                        <p:strVal val="visible"/>
+                                      </p:to>
+                                    </p:set>
+                                    <p:animEffect transition="in" filter="barn(inVertical)">
+                                      <p:cBhvr>
+                                        <p:cTn id="7" dur="500"/>
+                                        <p:tgtEl>
+                                          <p:spTgt spid="4"/>
+                                        </p:tgtEl>
+                                      </p:cBhvr>
+                                    </p:animEffect>
+                                  </p:childTnLst>
+                                </p:cTn>
+                              </p:par>
+                            </p:childTnLst>
+                          </p:cTn>
+                        </p:par>
+                      </p:childTnLst>
+                    </p:cTn>
+                  </p:par>
+                </p:childTnLst>
+              </p:cTn>
+              <p:prevCondLst>
+                <p:cond evt="onPrev" delay="0">
+                  <p:tgtEl>
+                    <p:sldTgt/>
+                  </p:tgtEl>
+                </p:cond>
+              </p:prevCondLst>
+              <p:nextCondLst>
+                <p:cond evt="onNext" delay="0">
+                  <p:tgtEl>
+                    <p:sldTgt/>
+                  </p:tgtEl>
+                </p:cond>
+              </p:nextCondLst>
+            </p:seq>
+          </p:childTnLst>
+        </p:cTn>
+      </p:par>
+    </p:tnLst>
+    <p:bldLst>
+      <p:bldP spid="4" grpId="0" animBg="1"/>
+    </p:bldLst>
+  </p:timing>
 </p:sld>
 </file>
 
@@ -8843,6 +9675,13 @@
   <p:clrMapOvr>
     <a:masterClrMapping/>
   </p:clrMapOvr>
+  <p:timing>
+    <p:tnLst>
+      <p:par>
+        <p:cTn id="1" dur="indefinite" restart="never" nodeType="tmRoot"/>
+      </p:par>
+    </p:tnLst>
+  </p:timing>
 </p:sld>
 </file>
 
@@ -9056,6 +9895,92 @@
   <p:clrMapOvr>
     <a:masterClrMapping/>
   </p:clrMapOvr>
+  <p:timing>
+    <p:tnLst>
+      <p:par>
+        <p:cTn id="1" dur="indefinite" restart="never" nodeType="tmRoot">
+          <p:childTnLst>
+            <p:seq concurrent="1" nextAc="seek">
+              <p:cTn id="2" dur="indefinite" nodeType="mainSeq">
+                <p:childTnLst>
+                  <p:par>
+                    <p:cTn id="3" fill="hold">
+                      <p:stCondLst>
+                        <p:cond delay="indefinite"/>
+                      </p:stCondLst>
+                      <p:childTnLst>
+                        <p:par>
+                          <p:cTn id="4" fill="hold">
+                            <p:stCondLst>
+                              <p:cond delay="0"/>
+                            </p:stCondLst>
+                            <p:childTnLst>
+                              <p:par>
+                                <p:cTn id="5" presetID="16" presetClass="entr" presetSubtype="21" fill="hold" grpId="0" nodeType="clickEffect">
+                                  <p:stCondLst>
+                                    <p:cond delay="0"/>
+                                  </p:stCondLst>
+                                  <p:childTnLst>
+                                    <p:set>
+                                      <p:cBhvr>
+                                        <p:cTn id="6" dur="1" fill="hold">
+                                          <p:stCondLst>
+                                            <p:cond delay="0"/>
+                                          </p:stCondLst>
+                                        </p:cTn>
+                                        <p:tgtEl>
+                                          <p:spTgt spid="4"/>
+                                        </p:tgtEl>
+                                        <p:attrNameLst>
+                                          <p:attrName>style.visibility</p:attrName>
+                                        </p:attrNameLst>
+                                      </p:cBhvr>
+                                      <p:to>
+                                        <p:strVal val="visible"/>
+                                      </p:to>
+                                    </p:set>
+                                    <p:animEffect transition="in" filter="barn(inVertical)">
+                                      <p:cBhvr>
+                                        <p:cTn id="7" dur="500"/>
+                                        <p:tgtEl>
+                                          <p:spTgt spid="4"/>
+                                        </p:tgtEl>
+                                      </p:cBhvr>
+                                    </p:animEffect>
+                                  </p:childTnLst>
+                                </p:cTn>
+                              </p:par>
+                            </p:childTnLst>
+                          </p:cTn>
+                        </p:par>
+                      </p:childTnLst>
+                    </p:cTn>
+                  </p:par>
+                </p:childTnLst>
+              </p:cTn>
+              <p:prevCondLst>
+                <p:cond evt="onPrev" delay="0">
+                  <p:tgtEl>
+                    <p:sldTgt/>
+                  </p:tgtEl>
+                </p:cond>
+              </p:prevCondLst>
+              <p:nextCondLst>
+                <p:cond evt="onNext" delay="0">
+                  <p:tgtEl>
+                    <p:sldTgt/>
+                  </p:tgtEl>
+                </p:cond>
+              </p:nextCondLst>
+            </p:seq>
+          </p:childTnLst>
+        </p:cTn>
+      </p:par>
+    </p:tnLst>
+    <p:bldLst>
+      <p:bldP spid="4" grpId="0" animBg="1"/>
+    </p:bldLst>
+  </p:timing>
 </p:sld>
 </file>
 
@@ -9141,14 +10066,14 @@
           <p:nvPr>
             <p:extLst>
               <p:ext uri="{D42A27DB-BD31-4B8C-83A1-F6EECF244321}">
-                <p14:modId xmlns:p14="http://schemas.microsoft.com/office/powerpoint/2010/main" val="1579011935"/>
+                <p14:modId xmlns:p14="http://schemas.microsoft.com/office/powerpoint/2010/main" val="2799271219"/>
               </p:ext>
             </p:extLst>
           </p:nvPr>
         </p:nvGraphicFramePr>
         <p:xfrm>
           <a:off x="825500" y="1473200"/>
-          <a:ext cx="10553700" cy="3088084"/>
+          <a:ext cx="10553700" cy="3088088"/>
         </p:xfrm>
         <a:graphic>
           <a:graphicData uri="http://schemas.openxmlformats.org/drawingml/2006/table">
@@ -9158,14 +10083,14 @@
                 <a:gridCol w="5276850">
                   <a:extLst>
                     <a:ext uri="{9D8B030D-6E8A-4147-A177-3AD203B41FA5}">
-                      <a16:colId xmlns:a16="http://schemas.microsoft.com/office/drawing/2014/main" val="20000"/>
+                      <a16:colId xmlns="" xmlns:a16="http://schemas.microsoft.com/office/drawing/2014/main" val="20000"/>
                     </a:ext>
                   </a:extLst>
                 </a:gridCol>
                 <a:gridCol w="5276850">
                   <a:extLst>
                     <a:ext uri="{9D8B030D-6E8A-4147-A177-3AD203B41FA5}">
-                      <a16:colId xmlns:a16="http://schemas.microsoft.com/office/drawing/2014/main" val="20001"/>
+                      <a16:colId xmlns="" xmlns:a16="http://schemas.microsoft.com/office/drawing/2014/main" val="20001"/>
                     </a:ext>
                   </a:extLst>
                 </a:gridCol>
@@ -9315,7 +10240,7 @@
                 </a:tc>
                 <a:extLst>
                   <a:ext uri="{0D108BD9-81ED-4DB2-BD59-A6C34878D82A}">
-                    <a16:rowId xmlns:a16="http://schemas.microsoft.com/office/drawing/2014/main" val="10000"/>
+                    <a16:rowId xmlns="" xmlns:a16="http://schemas.microsoft.com/office/drawing/2014/main" val="10000"/>
                   </a:ext>
                 </a:extLst>
               </a:tr>
@@ -9399,17 +10324,6 @@
                         </a:lnSpc>
                         <a:buNone/>
                       </a:pPr>
-                      <a:r>
-                        <a:rPr lang="en-US" sz="1400" dirty="0">
-                          <a:solidFill>
-                            <a:srgbClr val="1B2A41"/>
-                          </a:solidFill>
-                          <a:latin typeface="Helvetica" pitchFamily="34" charset="0"/>
-                          <a:ea typeface="Helvetica" pitchFamily="34" charset="-122"/>
-                          <a:cs typeface="Helvetica" pitchFamily="34" charset="-120"/>
-                        </a:rPr>
-                        <a:t>Open the CSV, return header and rows</a:t>
-                      </a:r>
                       <a:endParaRPr lang="en-US" sz="1400" dirty="0">
                         <a:latin typeface="Helvetica" charset="0"/>
                         <a:ea typeface="Helvetica" charset="0"/>
@@ -9458,7 +10372,7 @@
                 </a:tc>
                 <a:extLst>
                   <a:ext uri="{0D108BD9-81ED-4DB2-BD59-A6C34878D82A}">
-                    <a16:rowId xmlns:a16="http://schemas.microsoft.com/office/drawing/2014/main" val="10001"/>
+                    <a16:rowId xmlns="" xmlns:a16="http://schemas.microsoft.com/office/drawing/2014/main" val="10001"/>
                   </a:ext>
                 </a:extLst>
               </a:tr>
@@ -9542,17 +10456,6 @@
                         </a:lnSpc>
                         <a:buNone/>
                       </a:pPr>
-                      <a:r>
-                        <a:rPr lang="en-US" sz="1400" dirty="0">
-                          <a:solidFill>
-                            <a:srgbClr val="1B2A41"/>
-                          </a:solidFill>
-                          <a:latin typeface="Helvetica" pitchFamily="34" charset="0"/>
-                          <a:ea typeface="Helvetica" pitchFamily="34" charset="-122"/>
-                          <a:cs typeface="Helvetica" pitchFamily="34" charset="-120"/>
-                        </a:rPr>
-                        <a:t>True for blank, N/A, ?, null and similar</a:t>
-                      </a:r>
                       <a:endParaRPr lang="en-US" sz="1400" dirty="0">
                         <a:latin typeface="Helvetica" charset="0"/>
                         <a:ea typeface="Helvetica" charset="0"/>
@@ -9601,7 +10504,7 @@
                 </a:tc>
                 <a:extLst>
                   <a:ext uri="{0D108BD9-81ED-4DB2-BD59-A6C34878D82A}">
-                    <a16:rowId xmlns:a16="http://schemas.microsoft.com/office/drawing/2014/main" val="10002"/>
+                    <a16:rowId xmlns="" xmlns:a16="http://schemas.microsoft.com/office/drawing/2014/main" val="10002"/>
                   </a:ext>
                 </a:extLst>
               </a:tr>
@@ -9685,17 +10588,6 @@
                         </a:lnSpc>
                         <a:buNone/>
                       </a:pPr>
-                      <a:r>
-                        <a:rPr lang="en-US" sz="1400" dirty="0">
-                          <a:solidFill>
-                            <a:srgbClr val="1B2A41"/>
-                          </a:solidFill>
-                          <a:latin typeface="Helvetica" pitchFamily="34" charset="0"/>
-                          <a:ea typeface="Helvetica" pitchFamily="34" charset="-122"/>
-                          <a:cs typeface="Helvetica" pitchFamily="34" charset="-120"/>
-                        </a:rPr>
-                        <a:t>Decide int, float, str or empty for one column</a:t>
-                      </a:r>
                       <a:endParaRPr lang="en-US" sz="1400" dirty="0">
                         <a:latin typeface="Helvetica" charset="0"/>
                         <a:ea typeface="Helvetica" charset="0"/>
@@ -9744,7 +10636,7 @@
                 </a:tc>
                 <a:extLst>
                   <a:ext uri="{0D108BD9-81ED-4DB2-BD59-A6C34878D82A}">
-                    <a16:rowId xmlns:a16="http://schemas.microsoft.com/office/drawing/2014/main" val="10003"/>
+                    <a16:rowId xmlns="" xmlns:a16="http://schemas.microsoft.com/office/drawing/2014/main" val="10003"/>
                   </a:ext>
                 </a:extLst>
               </a:tr>
@@ -9828,17 +10720,6 @@
                         </a:lnSpc>
                         <a:buNone/>
                       </a:pPr>
-                      <a:r>
-                        <a:rPr lang="en-US" sz="1400" dirty="0">
-                          <a:solidFill>
-                            <a:srgbClr val="1B2A41"/>
-                          </a:solidFill>
-                          <a:latin typeface="Helvetica" pitchFamily="34" charset="0"/>
-                          <a:ea typeface="Helvetica" pitchFamily="34" charset="-122"/>
-                          <a:cs typeface="Helvetica" pitchFamily="34" charset="-120"/>
-                        </a:rPr>
-                        <a:t>Turn one column into a summary</a:t>
-                      </a:r>
                       <a:endParaRPr lang="en-US" sz="1400" dirty="0">
                         <a:latin typeface="Helvetica" charset="0"/>
                         <a:ea typeface="Helvetica" charset="0"/>
@@ -9887,7 +10768,7 @@
                 </a:tc>
                 <a:extLst>
                   <a:ext uri="{0D108BD9-81ED-4DB2-BD59-A6C34878D82A}">
-                    <a16:rowId xmlns:a16="http://schemas.microsoft.com/office/drawing/2014/main" val="10004"/>
+                    <a16:rowId xmlns="" xmlns:a16="http://schemas.microsoft.com/office/drawing/2014/main" val="10004"/>
                   </a:ext>
                 </a:extLst>
               </a:tr>
@@ -9971,17 +10852,6 @@
                         </a:lnSpc>
                         <a:buNone/>
                       </a:pPr>
-                      <a:r>
-                        <a:rPr lang="en-US" sz="1400" dirty="0">
-                          <a:solidFill>
-                            <a:srgbClr val="1B2A41"/>
-                          </a:solidFill>
-                          <a:latin typeface="Helvetica" pitchFamily="34" charset="0"/>
-                          <a:ea typeface="Helvetica" pitchFamily="34" charset="-122"/>
-                          <a:cs typeface="Helvetica" pitchFamily="34" charset="-120"/>
-                        </a:rPr>
-                        <a:t>List columns that hold identical values</a:t>
-                      </a:r>
                       <a:endParaRPr lang="en-US" sz="1400" dirty="0">
                         <a:latin typeface="Helvetica" charset="0"/>
                         <a:ea typeface="Helvetica" charset="0"/>
@@ -10030,7 +10900,7 @@
                 </a:tc>
                 <a:extLst>
                   <a:ext uri="{0D108BD9-81ED-4DB2-BD59-A6C34878D82A}">
-                    <a16:rowId xmlns:a16="http://schemas.microsoft.com/office/drawing/2014/main" val="10005"/>
+                    <a16:rowId xmlns="" xmlns:a16="http://schemas.microsoft.com/office/drawing/2014/main" val="10005"/>
                   </a:ext>
                 </a:extLst>
               </a:tr>
@@ -10114,17 +10984,6 @@
                         </a:lnSpc>
                         <a:buNone/>
                       </a:pPr>
-                      <a:r>
-                        <a:rPr lang="en-US" sz="1400" dirty="0">
-                          <a:solidFill>
-                            <a:srgbClr val="1B2A41"/>
-                          </a:solidFill>
-                          <a:latin typeface="Helvetica" pitchFamily="34" charset="0"/>
-                          <a:ea typeface="Helvetica" pitchFamily="34" charset="-122"/>
-                          <a:cs typeface="Helvetica" pitchFamily="34" charset="-120"/>
-                        </a:rPr>
-                        <a:t>Print everything for one file</a:t>
-                      </a:r>
                       <a:endParaRPr lang="en-US" sz="1400" dirty="0">
                         <a:latin typeface="Helvetica" charset="0"/>
                         <a:ea typeface="Helvetica" charset="0"/>
@@ -10173,7 +11032,7 @@
                 </a:tc>
                 <a:extLst>
                   <a:ext uri="{0D108BD9-81ED-4DB2-BD59-A6C34878D82A}">
-                    <a16:rowId xmlns:a16="http://schemas.microsoft.com/office/drawing/2014/main" val="10006"/>
+                    <a16:rowId xmlns="" xmlns:a16="http://schemas.microsoft.com/office/drawing/2014/main" val="10006"/>
                   </a:ext>
                 </a:extLst>
               </a:tr>
@@ -10257,17 +11116,6 @@
                         </a:lnSpc>
                         <a:buNone/>
                       </a:pPr>
-                      <a:r>
-                        <a:rPr lang="en-US" sz="1400" dirty="0">
-                          <a:solidFill>
-                            <a:srgbClr val="1B2A41"/>
-                          </a:solidFill>
-                          <a:latin typeface="Helvetica" pitchFamily="34" charset="0"/>
-                          <a:ea typeface="Helvetica" pitchFamily="34" charset="-122"/>
-                          <a:cs typeface="Helvetica" pitchFamily="34" charset="-120"/>
-                        </a:rPr>
-                        <a:t>Handle arguments and errors</a:t>
-                      </a:r>
                       <a:endParaRPr lang="en-US" sz="1400" dirty="0">
                         <a:latin typeface="Helvetica" charset="0"/>
                         <a:ea typeface="Helvetica" charset="0"/>
@@ -10316,7 +11164,7 @@
                 </a:tc>
                 <a:extLst>
                   <a:ext uri="{0D108BD9-81ED-4DB2-BD59-A6C34878D82A}">
-                    <a16:rowId xmlns:a16="http://schemas.microsoft.com/office/drawing/2014/main" val="10007"/>
+                    <a16:rowId xmlns="" xmlns:a16="http://schemas.microsoft.com/office/drawing/2014/main" val="10007"/>
                   </a:ext>
                 </a:extLst>
               </a:tr>
@@ -10412,11 +11260,778 @@
           </a:p>
         </p:txBody>
       </p:sp>
+      <p:sp>
+        <p:nvSpPr>
+          <p:cNvPr id="6" name="TextBox 5"/>
+          <p:cNvSpPr txBox="1"/>
+          <p:nvPr/>
+        </p:nvSpPr>
+        <p:spPr>
+          <a:xfrm>
+            <a:off x="6162130" y="1895947"/>
+            <a:ext cx="4696370" cy="307777"/>
+          </a:xfrm>
+          <a:prstGeom prst="rect">
+            <a:avLst/>
+          </a:prstGeom>
+          <a:noFill/>
+        </p:spPr>
+        <p:txBody>
+          <a:bodyPr wrap="square" rtlCol="0">
+            <a:spAutoFit/>
+          </a:bodyPr>
+          <a:lstStyle/>
+          <a:p>
+            <a:r>
+              <a:rPr lang="en-US" sz="1400" dirty="0">
+                <a:solidFill>
+                  <a:srgbClr val="1B2A41"/>
+                </a:solidFill>
+                <a:latin typeface="Helvetica" pitchFamily="34" charset="0"/>
+                <a:ea typeface="Helvetica" pitchFamily="34" charset="-122"/>
+                <a:cs typeface="Helvetica" pitchFamily="34" charset="-120"/>
+              </a:rPr>
+              <a:t>Open the CSV, return header and rows</a:t>
+            </a:r>
+            <a:endParaRPr lang="en-US" sz="1400" dirty="0"/>
+          </a:p>
+        </p:txBody>
+      </p:sp>
+      <p:sp>
+        <p:nvSpPr>
+          <p:cNvPr id="7" name="TextBox 6"/>
+          <p:cNvSpPr txBox="1"/>
+          <p:nvPr/>
+        </p:nvSpPr>
+        <p:spPr>
+          <a:xfrm>
+            <a:off x="6162130" y="2259911"/>
+            <a:ext cx="4696370" cy="325538"/>
+          </a:xfrm>
+          <a:prstGeom prst="rect">
+            <a:avLst/>
+          </a:prstGeom>
+          <a:noFill/>
+        </p:spPr>
+        <p:txBody>
+          <a:bodyPr wrap="square" rtlCol="0">
+            <a:spAutoFit/>
+          </a:bodyPr>
+          <a:lstStyle/>
+          <a:p>
+            <a:pPr>
+              <a:lnSpc>
+                <a:spcPts val="1960"/>
+              </a:lnSpc>
+            </a:pPr>
+            <a:r>
+              <a:rPr lang="en-US" sz="1400" dirty="0">
+                <a:solidFill>
+                  <a:srgbClr val="1B2A41"/>
+                </a:solidFill>
+                <a:latin typeface="Helvetica" pitchFamily="34" charset="0"/>
+                <a:ea typeface="Helvetica" pitchFamily="34" charset="-122"/>
+                <a:cs typeface="Helvetica" pitchFamily="34" charset="-120"/>
+              </a:rPr>
+              <a:t>True for blank, N/A, ?, null and similar</a:t>
+            </a:r>
+            <a:endParaRPr lang="en-US" sz="1400" dirty="0">
+              <a:latin typeface="Helvetica" charset="0"/>
+              <a:ea typeface="Helvetica" charset="0"/>
+              <a:cs typeface="Helvetica" charset="0"/>
+            </a:endParaRPr>
+          </a:p>
+        </p:txBody>
+      </p:sp>
+      <p:sp>
+        <p:nvSpPr>
+          <p:cNvPr id="8" name="TextBox 7"/>
+          <p:cNvSpPr txBox="1"/>
+          <p:nvPr/>
+        </p:nvSpPr>
+        <p:spPr>
+          <a:xfrm>
+            <a:off x="6162130" y="2641636"/>
+            <a:ext cx="4696370" cy="325538"/>
+          </a:xfrm>
+          <a:prstGeom prst="rect">
+            <a:avLst/>
+          </a:prstGeom>
+          <a:noFill/>
+        </p:spPr>
+        <p:txBody>
+          <a:bodyPr wrap="square" rtlCol="0">
+            <a:spAutoFit/>
+          </a:bodyPr>
+          <a:lstStyle/>
+          <a:p>
+            <a:pPr>
+              <a:lnSpc>
+                <a:spcPts val="1960"/>
+              </a:lnSpc>
+            </a:pPr>
+            <a:r>
+              <a:rPr lang="en-US" sz="1400" dirty="0">
+                <a:solidFill>
+                  <a:srgbClr val="1B2A41"/>
+                </a:solidFill>
+                <a:latin typeface="Helvetica" pitchFamily="34" charset="0"/>
+                <a:ea typeface="Helvetica" pitchFamily="34" charset="-122"/>
+                <a:cs typeface="Helvetica" pitchFamily="34" charset="-120"/>
+              </a:rPr>
+              <a:t>Decide </a:t>
+            </a:r>
+            <a:r>
+              <a:rPr lang="en-US" sz="1400" dirty="0" err="1">
+                <a:solidFill>
+                  <a:srgbClr val="1B2A41"/>
+                </a:solidFill>
+                <a:latin typeface="Helvetica" pitchFamily="34" charset="0"/>
+                <a:ea typeface="Helvetica" pitchFamily="34" charset="-122"/>
+                <a:cs typeface="Helvetica" pitchFamily="34" charset="-120"/>
+              </a:rPr>
+              <a:t>int</a:t>
+            </a:r>
+            <a:r>
+              <a:rPr lang="en-US" sz="1400" dirty="0">
+                <a:solidFill>
+                  <a:srgbClr val="1B2A41"/>
+                </a:solidFill>
+                <a:latin typeface="Helvetica" pitchFamily="34" charset="0"/>
+                <a:ea typeface="Helvetica" pitchFamily="34" charset="-122"/>
+                <a:cs typeface="Helvetica" pitchFamily="34" charset="-120"/>
+              </a:rPr>
+              <a:t>, float, </a:t>
+            </a:r>
+            <a:r>
+              <a:rPr lang="en-US" sz="1400" dirty="0" err="1">
+                <a:solidFill>
+                  <a:srgbClr val="1B2A41"/>
+                </a:solidFill>
+                <a:latin typeface="Helvetica" pitchFamily="34" charset="0"/>
+                <a:ea typeface="Helvetica" pitchFamily="34" charset="-122"/>
+                <a:cs typeface="Helvetica" pitchFamily="34" charset="-120"/>
+              </a:rPr>
+              <a:t>str</a:t>
+            </a:r>
+            <a:r>
+              <a:rPr lang="en-US" sz="1400" dirty="0">
+                <a:solidFill>
+                  <a:srgbClr val="1B2A41"/>
+                </a:solidFill>
+                <a:latin typeface="Helvetica" pitchFamily="34" charset="0"/>
+                <a:ea typeface="Helvetica" pitchFamily="34" charset="-122"/>
+                <a:cs typeface="Helvetica" pitchFamily="34" charset="-120"/>
+              </a:rPr>
+              <a:t> or empty for one column</a:t>
+            </a:r>
+            <a:endParaRPr lang="en-US" sz="1400" dirty="0">
+              <a:latin typeface="Helvetica" charset="0"/>
+              <a:ea typeface="Helvetica" charset="0"/>
+              <a:cs typeface="Helvetica" charset="0"/>
+            </a:endParaRPr>
+          </a:p>
+        </p:txBody>
+      </p:sp>
+      <p:sp>
+        <p:nvSpPr>
+          <p:cNvPr id="9" name="TextBox 8"/>
+          <p:cNvSpPr txBox="1"/>
+          <p:nvPr/>
+        </p:nvSpPr>
+        <p:spPr>
+          <a:xfrm>
+            <a:off x="6162130" y="3063806"/>
+            <a:ext cx="4696370" cy="325538"/>
+          </a:xfrm>
+          <a:prstGeom prst="rect">
+            <a:avLst/>
+          </a:prstGeom>
+          <a:noFill/>
+        </p:spPr>
+        <p:txBody>
+          <a:bodyPr wrap="square" rtlCol="0">
+            <a:spAutoFit/>
+          </a:bodyPr>
+          <a:lstStyle/>
+          <a:p>
+            <a:pPr>
+              <a:lnSpc>
+                <a:spcPts val="1960"/>
+              </a:lnSpc>
+            </a:pPr>
+            <a:r>
+              <a:rPr lang="en-US" sz="1400" dirty="0">
+                <a:solidFill>
+                  <a:srgbClr val="1B2A41"/>
+                </a:solidFill>
+                <a:latin typeface="Helvetica" pitchFamily="34" charset="0"/>
+                <a:ea typeface="Helvetica" pitchFamily="34" charset="-122"/>
+                <a:cs typeface="Helvetica" pitchFamily="34" charset="-120"/>
+              </a:rPr>
+              <a:t>Turn one column into a summary</a:t>
+            </a:r>
+            <a:endParaRPr lang="en-US" sz="1400" dirty="0">
+              <a:latin typeface="Helvetica" charset="0"/>
+              <a:ea typeface="Helvetica" charset="0"/>
+              <a:cs typeface="Helvetica" charset="0"/>
+            </a:endParaRPr>
+          </a:p>
+        </p:txBody>
+      </p:sp>
+      <p:sp>
+        <p:nvSpPr>
+          <p:cNvPr id="10" name="TextBox 9"/>
+          <p:cNvSpPr txBox="1"/>
+          <p:nvPr/>
+        </p:nvSpPr>
+        <p:spPr>
+          <a:xfrm>
+            <a:off x="6162130" y="3443055"/>
+            <a:ext cx="4696370" cy="325538"/>
+          </a:xfrm>
+          <a:prstGeom prst="rect">
+            <a:avLst/>
+          </a:prstGeom>
+          <a:noFill/>
+        </p:spPr>
+        <p:txBody>
+          <a:bodyPr wrap="square" rtlCol="0">
+            <a:spAutoFit/>
+          </a:bodyPr>
+          <a:lstStyle/>
+          <a:p>
+            <a:pPr>
+              <a:lnSpc>
+                <a:spcPts val="1960"/>
+              </a:lnSpc>
+            </a:pPr>
+            <a:r>
+              <a:rPr lang="en-US" sz="1400" dirty="0">
+                <a:solidFill>
+                  <a:srgbClr val="1B2A41"/>
+                </a:solidFill>
+                <a:latin typeface="Helvetica" pitchFamily="34" charset="0"/>
+                <a:ea typeface="Helvetica" pitchFamily="34" charset="-122"/>
+                <a:cs typeface="Helvetica" pitchFamily="34" charset="-120"/>
+              </a:rPr>
+              <a:t>List columns that hold identical values</a:t>
+            </a:r>
+            <a:endParaRPr lang="en-US" sz="1400" dirty="0">
+              <a:latin typeface="Helvetica" charset="0"/>
+              <a:ea typeface="Helvetica" charset="0"/>
+              <a:cs typeface="Helvetica" charset="0"/>
+            </a:endParaRPr>
+          </a:p>
+        </p:txBody>
+      </p:sp>
+      <p:sp>
+        <p:nvSpPr>
+          <p:cNvPr id="11" name="TextBox 10"/>
+          <p:cNvSpPr txBox="1"/>
+          <p:nvPr/>
+        </p:nvSpPr>
+        <p:spPr>
+          <a:xfrm>
+            <a:off x="6162130" y="3810532"/>
+            <a:ext cx="4696370" cy="325538"/>
+          </a:xfrm>
+          <a:prstGeom prst="rect">
+            <a:avLst/>
+          </a:prstGeom>
+          <a:noFill/>
+        </p:spPr>
+        <p:txBody>
+          <a:bodyPr wrap="square" rtlCol="0">
+            <a:spAutoFit/>
+          </a:bodyPr>
+          <a:lstStyle/>
+          <a:p>
+            <a:pPr>
+              <a:lnSpc>
+                <a:spcPts val="1960"/>
+              </a:lnSpc>
+            </a:pPr>
+            <a:r>
+              <a:rPr lang="en-US" sz="1400" dirty="0">
+                <a:solidFill>
+                  <a:srgbClr val="1B2A41"/>
+                </a:solidFill>
+                <a:latin typeface="Helvetica" pitchFamily="34" charset="0"/>
+                <a:ea typeface="Helvetica" pitchFamily="34" charset="-122"/>
+                <a:cs typeface="Helvetica" pitchFamily="34" charset="-120"/>
+              </a:rPr>
+              <a:t>Print everything for one file</a:t>
+            </a:r>
+            <a:endParaRPr lang="en-US" sz="1400" dirty="0">
+              <a:latin typeface="Helvetica" charset="0"/>
+              <a:ea typeface="Helvetica" charset="0"/>
+              <a:cs typeface="Helvetica" charset="0"/>
+            </a:endParaRPr>
+          </a:p>
+        </p:txBody>
+      </p:sp>
+      <p:sp>
+        <p:nvSpPr>
+          <p:cNvPr id="12" name="TextBox 11"/>
+          <p:cNvSpPr txBox="1"/>
+          <p:nvPr/>
+        </p:nvSpPr>
+        <p:spPr>
+          <a:xfrm>
+            <a:off x="6162130" y="4204945"/>
+            <a:ext cx="4696370" cy="325538"/>
+          </a:xfrm>
+          <a:prstGeom prst="rect">
+            <a:avLst/>
+          </a:prstGeom>
+          <a:noFill/>
+        </p:spPr>
+        <p:txBody>
+          <a:bodyPr wrap="square" rtlCol="0">
+            <a:spAutoFit/>
+          </a:bodyPr>
+          <a:lstStyle/>
+          <a:p>
+            <a:pPr>
+              <a:lnSpc>
+                <a:spcPts val="1960"/>
+              </a:lnSpc>
+            </a:pPr>
+            <a:r>
+              <a:rPr lang="en-US" sz="1400" dirty="0">
+                <a:solidFill>
+                  <a:srgbClr val="1B2A41"/>
+                </a:solidFill>
+                <a:latin typeface="Helvetica" pitchFamily="34" charset="0"/>
+                <a:ea typeface="Helvetica" pitchFamily="34" charset="-122"/>
+                <a:cs typeface="Helvetica" pitchFamily="34" charset="-120"/>
+              </a:rPr>
+              <a:t>Handle arguments and errors</a:t>
+            </a:r>
+            <a:endParaRPr lang="en-US" sz="1400" dirty="0">
+              <a:latin typeface="Helvetica" charset="0"/>
+              <a:ea typeface="Helvetica" charset="0"/>
+              <a:cs typeface="Helvetica" charset="0"/>
+            </a:endParaRPr>
+          </a:p>
+        </p:txBody>
+      </p:sp>
     </p:spTree>
   </p:cSld>
   <p:clrMapOvr>
     <a:masterClrMapping/>
   </p:clrMapOvr>
+  <p:timing>
+    <p:tnLst>
+      <p:par>
+        <p:cTn id="1" dur="indefinite" restart="never" nodeType="tmRoot">
+          <p:childTnLst>
+            <p:seq concurrent="1" nextAc="seek">
+              <p:cTn id="2" dur="indefinite" nodeType="mainSeq">
+                <p:childTnLst>
+                  <p:par>
+                    <p:cTn id="3" fill="hold">
+                      <p:stCondLst>
+                        <p:cond delay="indefinite"/>
+                      </p:stCondLst>
+                      <p:childTnLst>
+                        <p:par>
+                          <p:cTn id="4" fill="hold">
+                            <p:stCondLst>
+                              <p:cond delay="0"/>
+                            </p:stCondLst>
+                            <p:childTnLst>
+                              <p:par>
+                                <p:cTn id="5" presetID="16" presetClass="entr" presetSubtype="21" fill="hold" grpId="0" nodeType="clickEffect">
+                                  <p:stCondLst>
+                                    <p:cond delay="0"/>
+                                  </p:stCondLst>
+                                  <p:childTnLst>
+                                    <p:set>
+                                      <p:cBhvr>
+                                        <p:cTn id="6" dur="1" fill="hold">
+                                          <p:stCondLst>
+                                            <p:cond delay="0"/>
+                                          </p:stCondLst>
+                                        </p:cTn>
+                                        <p:tgtEl>
+                                          <p:spTgt spid="6"/>
+                                        </p:tgtEl>
+                                        <p:attrNameLst>
+                                          <p:attrName>style.visibility</p:attrName>
+                                        </p:attrNameLst>
+                                      </p:cBhvr>
+                                      <p:to>
+                                        <p:strVal val="visible"/>
+                                      </p:to>
+                                    </p:set>
+                                    <p:animEffect transition="in" filter="barn(inVertical)">
+                                      <p:cBhvr>
+                                        <p:cTn id="7" dur="500"/>
+                                        <p:tgtEl>
+                                          <p:spTgt spid="6"/>
+                                        </p:tgtEl>
+                                      </p:cBhvr>
+                                    </p:animEffect>
+                                  </p:childTnLst>
+                                </p:cTn>
+                              </p:par>
+                            </p:childTnLst>
+                          </p:cTn>
+                        </p:par>
+                      </p:childTnLst>
+                    </p:cTn>
+                  </p:par>
+                  <p:par>
+                    <p:cTn id="8" fill="hold">
+                      <p:stCondLst>
+                        <p:cond delay="indefinite"/>
+                      </p:stCondLst>
+                      <p:childTnLst>
+                        <p:par>
+                          <p:cTn id="9" fill="hold">
+                            <p:stCondLst>
+                              <p:cond delay="0"/>
+                            </p:stCondLst>
+                            <p:childTnLst>
+                              <p:par>
+                                <p:cTn id="10" presetID="16" presetClass="entr" presetSubtype="21" fill="hold" grpId="0" nodeType="clickEffect">
+                                  <p:stCondLst>
+                                    <p:cond delay="0"/>
+                                  </p:stCondLst>
+                                  <p:childTnLst>
+                                    <p:set>
+                                      <p:cBhvr>
+                                        <p:cTn id="11" dur="1" fill="hold">
+                                          <p:stCondLst>
+                                            <p:cond delay="0"/>
+                                          </p:stCondLst>
+                                        </p:cTn>
+                                        <p:tgtEl>
+                                          <p:spTgt spid="7"/>
+                                        </p:tgtEl>
+                                        <p:attrNameLst>
+                                          <p:attrName>style.visibility</p:attrName>
+                                        </p:attrNameLst>
+                                      </p:cBhvr>
+                                      <p:to>
+                                        <p:strVal val="visible"/>
+                                      </p:to>
+                                    </p:set>
+                                    <p:animEffect transition="in" filter="barn(inVertical)">
+                                      <p:cBhvr>
+                                        <p:cTn id="12" dur="500"/>
+                                        <p:tgtEl>
+                                          <p:spTgt spid="7"/>
+                                        </p:tgtEl>
+                                      </p:cBhvr>
+                                    </p:animEffect>
+                                  </p:childTnLst>
+                                </p:cTn>
+                              </p:par>
+                            </p:childTnLst>
+                          </p:cTn>
+                        </p:par>
+                      </p:childTnLst>
+                    </p:cTn>
+                  </p:par>
+                  <p:par>
+                    <p:cTn id="13" fill="hold">
+                      <p:stCondLst>
+                        <p:cond delay="indefinite"/>
+                      </p:stCondLst>
+                      <p:childTnLst>
+                        <p:par>
+                          <p:cTn id="14" fill="hold">
+                            <p:stCondLst>
+                              <p:cond delay="0"/>
+                            </p:stCondLst>
+                            <p:childTnLst>
+                              <p:par>
+                                <p:cTn id="15" presetID="16" presetClass="entr" presetSubtype="21" fill="hold" grpId="0" nodeType="clickEffect">
+                                  <p:stCondLst>
+                                    <p:cond delay="0"/>
+                                  </p:stCondLst>
+                                  <p:childTnLst>
+                                    <p:set>
+                                      <p:cBhvr>
+                                        <p:cTn id="16" dur="1" fill="hold">
+                                          <p:stCondLst>
+                                            <p:cond delay="0"/>
+                                          </p:stCondLst>
+                                        </p:cTn>
+                                        <p:tgtEl>
+                                          <p:spTgt spid="8"/>
+                                        </p:tgtEl>
+                                        <p:attrNameLst>
+                                          <p:attrName>style.visibility</p:attrName>
+                                        </p:attrNameLst>
+                                      </p:cBhvr>
+                                      <p:to>
+                                        <p:strVal val="visible"/>
+                                      </p:to>
+                                    </p:set>
+                                    <p:animEffect transition="in" filter="barn(inVertical)">
+                                      <p:cBhvr>
+                                        <p:cTn id="17" dur="500"/>
+                                        <p:tgtEl>
+                                          <p:spTgt spid="8"/>
+                                        </p:tgtEl>
+                                      </p:cBhvr>
+                                    </p:animEffect>
+                                  </p:childTnLst>
+                                </p:cTn>
+                              </p:par>
+                            </p:childTnLst>
+                          </p:cTn>
+                        </p:par>
+                      </p:childTnLst>
+                    </p:cTn>
+                  </p:par>
+                  <p:par>
+                    <p:cTn id="18" fill="hold">
+                      <p:stCondLst>
+                        <p:cond delay="indefinite"/>
+                      </p:stCondLst>
+                      <p:childTnLst>
+                        <p:par>
+                          <p:cTn id="19" fill="hold">
+                            <p:stCondLst>
+                              <p:cond delay="0"/>
+                            </p:stCondLst>
+                            <p:childTnLst>
+                              <p:par>
+                                <p:cTn id="20" presetID="16" presetClass="entr" presetSubtype="21" fill="hold" grpId="0" nodeType="clickEffect">
+                                  <p:stCondLst>
+                                    <p:cond delay="0"/>
+                                  </p:stCondLst>
+                                  <p:childTnLst>
+                                    <p:set>
+                                      <p:cBhvr>
+                                        <p:cTn id="21" dur="1" fill="hold">
+                                          <p:stCondLst>
+                                            <p:cond delay="0"/>
+                                          </p:stCondLst>
+                                        </p:cTn>
+                                        <p:tgtEl>
+                                          <p:spTgt spid="9"/>
+                                        </p:tgtEl>
+                                        <p:attrNameLst>
+                                          <p:attrName>style.visibility</p:attrName>
+                                        </p:attrNameLst>
+                                      </p:cBhvr>
+                                      <p:to>
+                                        <p:strVal val="visible"/>
+                                      </p:to>
+                                    </p:set>
+                                    <p:animEffect transition="in" filter="barn(inVertical)">
+                                      <p:cBhvr>
+                                        <p:cTn id="22" dur="500"/>
+                                        <p:tgtEl>
+                                          <p:spTgt spid="9"/>
+                                        </p:tgtEl>
+                                      </p:cBhvr>
+                                    </p:animEffect>
+                                  </p:childTnLst>
+                                </p:cTn>
+                              </p:par>
+                            </p:childTnLst>
+                          </p:cTn>
+                        </p:par>
+                      </p:childTnLst>
+                    </p:cTn>
+                  </p:par>
+                  <p:par>
+                    <p:cTn id="23" fill="hold">
+                      <p:stCondLst>
+                        <p:cond delay="indefinite"/>
+                      </p:stCondLst>
+                      <p:childTnLst>
+                        <p:par>
+                          <p:cTn id="24" fill="hold">
+                            <p:stCondLst>
+                              <p:cond delay="0"/>
+                            </p:stCondLst>
+                            <p:childTnLst>
+                              <p:par>
+                                <p:cTn id="25" presetID="16" presetClass="entr" presetSubtype="21" fill="hold" grpId="0" nodeType="clickEffect">
+                                  <p:stCondLst>
+                                    <p:cond delay="0"/>
+                                  </p:stCondLst>
+                                  <p:childTnLst>
+                                    <p:set>
+                                      <p:cBhvr>
+                                        <p:cTn id="26" dur="1" fill="hold">
+                                          <p:stCondLst>
+                                            <p:cond delay="0"/>
+                                          </p:stCondLst>
+                                        </p:cTn>
+                                        <p:tgtEl>
+                                          <p:spTgt spid="10"/>
+                                        </p:tgtEl>
+                                        <p:attrNameLst>
+                                          <p:attrName>style.visibility</p:attrName>
+                                        </p:attrNameLst>
+                                      </p:cBhvr>
+                                      <p:to>
+                                        <p:strVal val="visible"/>
+                                      </p:to>
+                                    </p:set>
+                                    <p:animEffect transition="in" filter="barn(inVertical)">
+                                      <p:cBhvr>
+                                        <p:cTn id="27" dur="500"/>
+                                        <p:tgtEl>
+                                          <p:spTgt spid="10"/>
+                                        </p:tgtEl>
+                                      </p:cBhvr>
+                                    </p:animEffect>
+                                  </p:childTnLst>
+                                </p:cTn>
+                              </p:par>
+                            </p:childTnLst>
+                          </p:cTn>
+                        </p:par>
+                      </p:childTnLst>
+                    </p:cTn>
+                  </p:par>
+                  <p:par>
+                    <p:cTn id="28" fill="hold">
+                      <p:stCondLst>
+                        <p:cond delay="indefinite"/>
+                      </p:stCondLst>
+                      <p:childTnLst>
+                        <p:par>
+                          <p:cTn id="29" fill="hold">
+                            <p:stCondLst>
+                              <p:cond delay="0"/>
+                            </p:stCondLst>
+                            <p:childTnLst>
+                              <p:par>
+                                <p:cTn id="30" presetID="16" presetClass="entr" presetSubtype="21" fill="hold" grpId="0" nodeType="clickEffect">
+                                  <p:stCondLst>
+                                    <p:cond delay="0"/>
+                                  </p:stCondLst>
+                                  <p:childTnLst>
+                                    <p:set>
+                                      <p:cBhvr>
+                                        <p:cTn id="31" dur="1" fill="hold">
+                                          <p:stCondLst>
+                                            <p:cond delay="0"/>
+                                          </p:stCondLst>
+                                        </p:cTn>
+                                        <p:tgtEl>
+                                          <p:spTgt spid="11"/>
+                                        </p:tgtEl>
+                                        <p:attrNameLst>
+                                          <p:attrName>style.visibility</p:attrName>
+                                        </p:attrNameLst>
+                                      </p:cBhvr>
+                                      <p:to>
+                                        <p:strVal val="visible"/>
+                                      </p:to>
+                                    </p:set>
+                                    <p:animEffect transition="in" filter="barn(inVertical)">
+                                      <p:cBhvr>
+                                        <p:cTn id="32" dur="500"/>
+                                        <p:tgtEl>
+                                          <p:spTgt spid="11"/>
+                                        </p:tgtEl>
+                                      </p:cBhvr>
+                                    </p:animEffect>
+                                  </p:childTnLst>
+                                </p:cTn>
+                              </p:par>
+                            </p:childTnLst>
+                          </p:cTn>
+                        </p:par>
+                      </p:childTnLst>
+                    </p:cTn>
+                  </p:par>
+                  <p:par>
+                    <p:cTn id="33" fill="hold">
+                      <p:stCondLst>
+                        <p:cond delay="indefinite"/>
+                      </p:stCondLst>
+                      <p:childTnLst>
+                        <p:par>
+                          <p:cTn id="34" fill="hold">
+                            <p:stCondLst>
+                              <p:cond delay="0"/>
+                            </p:stCondLst>
+                            <p:childTnLst>
+                              <p:par>
+                                <p:cTn id="35" presetID="16" presetClass="entr" presetSubtype="21" fill="hold" grpId="0" nodeType="clickEffect">
+                                  <p:stCondLst>
+                                    <p:cond delay="0"/>
+                                  </p:stCondLst>
+                                  <p:childTnLst>
+                                    <p:set>
+                                      <p:cBhvr>
+                                        <p:cTn id="36" dur="1" fill="hold">
+                                          <p:stCondLst>
+                                            <p:cond delay="0"/>
+                                          </p:stCondLst>
+                                        </p:cTn>
+                                        <p:tgtEl>
+                                          <p:spTgt spid="12"/>
+                                        </p:tgtEl>
+                                        <p:attrNameLst>
+                                          <p:attrName>style.visibility</p:attrName>
+                                        </p:attrNameLst>
+                                      </p:cBhvr>
+                                      <p:to>
+                                        <p:strVal val="visible"/>
+                                      </p:to>
+                                    </p:set>
+                                    <p:animEffect transition="in" filter="barn(inVertical)">
+                                      <p:cBhvr>
+                                        <p:cTn id="37" dur="500"/>
+                                        <p:tgtEl>
+                                          <p:spTgt spid="12"/>
+                                        </p:tgtEl>
+                                      </p:cBhvr>
+                                    </p:animEffect>
+                                  </p:childTnLst>
+                                </p:cTn>
+                              </p:par>
+                            </p:childTnLst>
+                          </p:cTn>
+                        </p:par>
+                      </p:childTnLst>
+                    </p:cTn>
+                  </p:par>
+                </p:childTnLst>
+              </p:cTn>
+              <p:prevCondLst>
+                <p:cond evt="onPrev" delay="0">
+                  <p:tgtEl>
+                    <p:sldTgt/>
+                  </p:tgtEl>
+                </p:cond>
+              </p:prevCondLst>
+              <p:nextCondLst>
+                <p:cond evt="onNext" delay="0">
+                  <p:tgtEl>
+                    <p:sldTgt/>
+                  </p:tgtEl>
+                </p:cond>
+              </p:nextCondLst>
+            </p:seq>
+          </p:childTnLst>
+        </p:cTn>
+      </p:par>
+    </p:tnLst>
+    <p:bldLst>
+      <p:bldP spid="6" grpId="0"/>
+      <p:bldP spid="7" grpId="0"/>
+      <p:bldP spid="8" grpId="0"/>
+      <p:bldP spid="9" grpId="0"/>
+      <p:bldP spid="10" grpId="0"/>
+      <p:bldP spid="11" grpId="0"/>
+      <p:bldP spid="12" grpId="0"/>
+    </p:bldLst>
+  </p:timing>
 </p:sld>
 </file>
 
@@ -12334,6 +13949,13 @@
   <p:clrMapOvr>
     <a:masterClrMapping/>
   </p:clrMapOvr>
+  <p:timing>
+    <p:tnLst>
+      <p:par>
+        <p:cTn id="1" dur="indefinite" restart="never" nodeType="tmRoot"/>
+      </p:par>
+    </p:tnLst>
+  </p:timing>
 </p:sld>
 </file>
 
@@ -14158,6 +15780,13 @@
   <p:clrMapOvr>
     <a:masterClrMapping/>
   </p:clrMapOvr>
+  <p:timing>
+    <p:tnLst>
+      <p:par>
+        <p:cTn id="1" dur="indefinite" restart="never" nodeType="tmRoot"/>
+      </p:par>
+    </p:tnLst>
+  </p:timing>
 </p:sld>
 </file>
 
@@ -14273,17 +15902,20 @@
               <a:buNone/>
             </a:pPr>
             <a:r>
-              <a:rPr lang="en-US" sz="850" dirty="0">
+              <a:rPr lang="en-US" sz="1400" dirty="0">
                 <a:solidFill>
                   <a:srgbClr val="1B2A41"/>
                 </a:solidFill>
-                <a:latin typeface="Courier New" pitchFamily="49" charset="0"/>
-                <a:ea typeface="Courier New" pitchFamily="49" charset="-122"/>
-                <a:cs typeface="Courier New" pitchFamily="49" charset="-120"/>
+                <a:latin typeface="Courier New" panose="02070309020205020404" pitchFamily="49" charset="0"/>
+                <a:ea typeface="Courier New" pitchFamily="49" charset="-122"/>
+                <a:cs typeface="Courier New" panose="02070309020205020404" pitchFamily="49" charset="0"/>
               </a:rPr>
               <a:t>File: orders.csv</a:t>
             </a:r>
-            <a:endParaRPr lang="en-US" sz="850" dirty="0"/>
+            <a:endParaRPr lang="en-US" sz="1400" dirty="0">
+              <a:latin typeface="Courier New" panose="02070309020205020404" pitchFamily="49" charset="0"/>
+              <a:cs typeface="Courier New" panose="02070309020205020404" pitchFamily="49" charset="0"/>
+            </a:endParaRPr>
           </a:p>
           <a:p>
             <a:pPr marL="0" indent="0" algn="l">
@@ -14293,17 +15925,20 @@
               <a:buNone/>
             </a:pPr>
             <a:r>
-              <a:rPr lang="en-US" sz="850" dirty="0">
+              <a:rPr lang="en-US" sz="1400" dirty="0">
                 <a:solidFill>
                   <a:srgbClr val="1B2A41"/>
                 </a:solidFill>
                 <a:latin typeface="Courier New" pitchFamily="49" charset="0"/>
                 <a:ea typeface="Courier New" pitchFamily="49" charset="-122"/>
-                <a:cs typeface="Courier New" pitchFamily="49" charset="-120"/>
+                <a:cs typeface="Courier New" panose="02070309020205020404" pitchFamily="49" charset="0"/>
               </a:rPr>
               <a:t>Rows: 200  Columns: 10</a:t>
             </a:r>
-            <a:endParaRPr lang="en-US" sz="850" dirty="0"/>
+            <a:endParaRPr lang="en-US" sz="1400" dirty="0">
+              <a:latin typeface="Courier New" panose="02070309020205020404" pitchFamily="49" charset="0"/>
+              <a:cs typeface="Courier New" panose="02070309020205020404" pitchFamily="49" charset="0"/>
+            </a:endParaRPr>
           </a:p>
           <a:p>
             <a:pPr marL="0" indent="0" algn="l">
@@ -14313,17 +15948,20 @@
               <a:buNone/>
             </a:pPr>
             <a:r>
-              <a:rPr lang="en-US" sz="850" dirty="0">
+              <a:rPr lang="en-US" sz="1400" dirty="0">
                 <a:solidFill>
                   <a:srgbClr val="1B2A41"/>
                 </a:solidFill>
                 <a:latin typeface="Courier New" pitchFamily="49" charset="0"/>
                 <a:ea typeface="Courier New" pitchFamily="49" charset="-122"/>
-                <a:cs typeface="Courier New" pitchFamily="49" charset="-120"/>
+                <a:cs typeface="Courier New" panose="02070309020205020404" pitchFamily="49" charset="0"/>
               </a:rPr>
               <a:t>Malformed rows: 2</a:t>
             </a:r>
-            <a:endParaRPr lang="en-US" sz="850" dirty="0"/>
+            <a:endParaRPr lang="en-US" sz="1400" dirty="0">
+              <a:latin typeface="Courier New" panose="02070309020205020404" pitchFamily="49" charset="0"/>
+              <a:cs typeface="Courier New" panose="02070309020205020404" pitchFamily="49" charset="0"/>
+            </a:endParaRPr>
           </a:p>
           <a:p>
             <a:pPr marL="0" indent="0" algn="l">
@@ -14333,17 +15971,20 @@
               <a:buNone/>
             </a:pPr>
             <a:r>
-              <a:rPr lang="en-US" sz="850" dirty="0">
+              <a:rPr lang="en-US" sz="1400" dirty="0">
                 <a:solidFill>
                   <a:srgbClr val="1B2A41"/>
                 </a:solidFill>
                 <a:latin typeface="Courier New" pitchFamily="49" charset="0"/>
                 <a:ea typeface="Courier New" pitchFamily="49" charset="-122"/>
-                <a:cs typeface="Courier New" pitchFamily="49" charset="-120"/>
+                <a:cs typeface="Courier New" panose="02070309020205020404" pitchFamily="49" charset="0"/>
               </a:rPr>
               <a:t>- order_id: int, missing=0, unique=200, min=1001, max=1200, mean=1100.50, median=1100.5</a:t>
             </a:r>
-            <a:endParaRPr lang="en-US" sz="850" dirty="0"/>
+            <a:endParaRPr lang="en-US" sz="1400" dirty="0">
+              <a:latin typeface="Courier New" panose="02070309020205020404" pitchFamily="49" charset="0"/>
+              <a:cs typeface="Courier New" panose="02070309020205020404" pitchFamily="49" charset="0"/>
+            </a:endParaRPr>
           </a:p>
           <a:p>
             <a:pPr marL="0" indent="0" algn="l">
@@ -14353,17 +15994,20 @@
               <a:buNone/>
             </a:pPr>
             <a:r>
-              <a:rPr lang="en-US" sz="850" dirty="0">
+              <a:rPr lang="en-US" sz="1400" dirty="0">
                 <a:solidFill>
                   <a:srgbClr val="1B2A41"/>
                 </a:solidFill>
                 <a:latin typeface="Courier New" pitchFamily="49" charset="0"/>
                 <a:ea typeface="Courier New" pitchFamily="49" charset="-122"/>
-                <a:cs typeface="Courier New" pitchFamily="49" charset="-120"/>
+                <a:cs typeface="Courier New" panose="02070309020205020404" pitchFamily="49" charset="0"/>
               </a:rPr>
               <a:t>- customer_id: str, missing=0, unique=59</a:t>
             </a:r>
-            <a:endParaRPr lang="en-US" sz="850" dirty="0"/>
+            <a:endParaRPr lang="en-US" sz="1400" dirty="0">
+              <a:latin typeface="Courier New" panose="02070309020205020404" pitchFamily="49" charset="0"/>
+              <a:cs typeface="Courier New" panose="02070309020205020404" pitchFamily="49" charset="0"/>
+            </a:endParaRPr>
           </a:p>
           <a:p>
             <a:pPr marL="0" indent="0" algn="l">
@@ -14373,17 +16017,20 @@
               <a:buNone/>
             </a:pPr>
             <a:r>
-              <a:rPr lang="en-US" sz="850" dirty="0">
+              <a:rPr lang="en-US" sz="1400" dirty="0">
                 <a:solidFill>
                   <a:srgbClr val="1B2A41"/>
                 </a:solidFill>
                 <a:latin typeface="Courier New" pitchFamily="49" charset="0"/>
                 <a:ea typeface="Courier New" pitchFamily="49" charset="-122"/>
-                <a:cs typeface="Courier New" pitchFamily="49" charset="-120"/>
+                <a:cs typeface="Courier New" panose="02070309020205020404" pitchFamily="49" charset="0"/>
               </a:rPr>
               <a:t>- customer_ref: str, missing=0, unique=59</a:t>
             </a:r>
-            <a:endParaRPr lang="en-US" sz="850" dirty="0"/>
+            <a:endParaRPr lang="en-US" sz="1400" dirty="0">
+              <a:latin typeface="Courier New" panose="02070309020205020404" pitchFamily="49" charset="0"/>
+              <a:cs typeface="Courier New" panose="02070309020205020404" pitchFamily="49" charset="0"/>
+            </a:endParaRPr>
           </a:p>
           <a:p>
             <a:pPr marL="0" indent="0" algn="l">
@@ -14393,17 +16040,20 @@
               <a:buNone/>
             </a:pPr>
             <a:r>
-              <a:rPr lang="en-US" sz="850" dirty="0">
+              <a:rPr lang="en-US" sz="1400" dirty="0">
                 <a:solidFill>
                   <a:srgbClr val="1B2A41"/>
                 </a:solidFill>
                 <a:latin typeface="Courier New" pitchFamily="49" charset="0"/>
                 <a:ea typeface="Courier New" pitchFamily="49" charset="-122"/>
-                <a:cs typeface="Courier New" pitchFamily="49" charset="-120"/>
+                <a:cs typeface="Courier New" panose="02070309020205020404" pitchFamily="49" charset="0"/>
               </a:rPr>
               <a:t>- city: str, missing=0, unique=5</a:t>
             </a:r>
-            <a:endParaRPr lang="en-US" sz="850" dirty="0"/>
+            <a:endParaRPr lang="en-US" sz="1400" dirty="0">
+              <a:latin typeface="Courier New" panose="02070309020205020404" pitchFamily="49" charset="0"/>
+              <a:cs typeface="Courier New" panose="02070309020205020404" pitchFamily="49" charset="0"/>
+            </a:endParaRPr>
           </a:p>
           <a:p>
             <a:pPr marL="0" indent="0" algn="l">
@@ -14413,17 +16063,20 @@
               <a:buNone/>
             </a:pPr>
             <a:r>
-              <a:rPr lang="en-US" sz="850" dirty="0">
+              <a:rPr lang="en-US" sz="1400" dirty="0">
                 <a:solidFill>
                   <a:srgbClr val="1B2A41"/>
                 </a:solidFill>
                 <a:latin typeface="Courier New" pitchFamily="49" charset="0"/>
                 <a:ea typeface="Courier New" pitchFamily="49" charset="-122"/>
-                <a:cs typeface="Courier New" pitchFamily="49" charset="-120"/>
+                <a:cs typeface="Courier New" panose="02070309020205020404" pitchFamily="49" charset="0"/>
               </a:rPr>
               <a:t>- category: str, missing=0, unique=4</a:t>
             </a:r>
-            <a:endParaRPr lang="en-US" sz="850" dirty="0"/>
+            <a:endParaRPr lang="en-US" sz="1400" dirty="0">
+              <a:latin typeface="Courier New" panose="02070309020205020404" pitchFamily="49" charset="0"/>
+              <a:cs typeface="Courier New" panose="02070309020205020404" pitchFamily="49" charset="0"/>
+            </a:endParaRPr>
           </a:p>
           <a:p>
             <a:pPr marL="0" indent="0" algn="l">
@@ -14433,17 +16086,20 @@
               <a:buNone/>
             </a:pPr>
             <a:r>
-              <a:rPr lang="en-US" sz="850" dirty="0">
+              <a:rPr lang="en-US" sz="1400" dirty="0">
                 <a:solidFill>
                   <a:srgbClr val="1B2A41"/>
                 </a:solidFill>
                 <a:latin typeface="Courier New" pitchFamily="49" charset="0"/>
                 <a:ea typeface="Courier New" pitchFamily="49" charset="-122"/>
-                <a:cs typeface="Courier New" pitchFamily="49" charset="-120"/>
+                <a:cs typeface="Courier New" panose="02070309020205020404" pitchFamily="49" charset="0"/>
               </a:rPr>
               <a:t>- quantity: str, missing=2, unique=5</a:t>
             </a:r>
-            <a:endParaRPr lang="en-US" sz="850" dirty="0"/>
+            <a:endParaRPr lang="en-US" sz="1400" dirty="0">
+              <a:latin typeface="Courier New" panose="02070309020205020404" pitchFamily="49" charset="0"/>
+              <a:cs typeface="Courier New" panose="02070309020205020404" pitchFamily="49" charset="0"/>
+            </a:endParaRPr>
           </a:p>
           <a:p>
             <a:pPr marL="0" indent="0" algn="l">
@@ -14453,17 +16109,20 @@
               <a:buNone/>
             </a:pPr>
             <a:r>
-              <a:rPr lang="en-US" sz="850" dirty="0">
+              <a:rPr lang="en-US" sz="1400" dirty="0">
                 <a:solidFill>
                   <a:srgbClr val="1B2A41"/>
                 </a:solidFill>
                 <a:latin typeface="Courier New" pitchFamily="49" charset="0"/>
                 <a:ea typeface="Courier New" pitchFamily="49" charset="-122"/>
-                <a:cs typeface="Courier New" pitchFamily="49" charset="-120"/>
+                <a:cs typeface="Courier New" panose="02070309020205020404" pitchFamily="49" charset="0"/>
               </a:rPr>
               <a:t>- unit_price: int, missing=3, unique=100, min=100, max=8850, mean=2680.71, median=2100</a:t>
             </a:r>
-            <a:endParaRPr lang="en-US" sz="850" dirty="0"/>
+            <a:endParaRPr lang="en-US" sz="1400" dirty="0">
+              <a:latin typeface="Courier New" panose="02070309020205020404" pitchFamily="49" charset="0"/>
+              <a:cs typeface="Courier New" panose="02070309020205020404" pitchFamily="49" charset="0"/>
+            </a:endParaRPr>
           </a:p>
           <a:p>
             <a:pPr marL="0" indent="0" algn="l">
@@ -14473,17 +16132,20 @@
               <a:buNone/>
             </a:pPr>
             <a:r>
-              <a:rPr lang="en-US" sz="850" dirty="0">
+              <a:rPr lang="en-US" sz="1400" dirty="0">
                 <a:solidFill>
                   <a:srgbClr val="1B2A41"/>
                 </a:solidFill>
                 <a:latin typeface="Courier New" pitchFamily="49" charset="0"/>
                 <a:ea typeface="Courier New" pitchFamily="49" charset="-122"/>
-                <a:cs typeface="Courier New" pitchFamily="49" charset="-120"/>
+                <a:cs typeface="Courier New" panose="02070309020205020404" pitchFamily="49" charset="0"/>
               </a:rPr>
               <a:t>- order_date: str, missing=5, unique=101</a:t>
             </a:r>
-            <a:endParaRPr lang="en-US" sz="850" dirty="0"/>
+            <a:endParaRPr lang="en-US" sz="1400" dirty="0">
+              <a:latin typeface="Courier New" panose="02070309020205020404" pitchFamily="49" charset="0"/>
+              <a:cs typeface="Courier New" panose="02070309020205020404" pitchFamily="49" charset="0"/>
+            </a:endParaRPr>
           </a:p>
           <a:p>
             <a:pPr marL="0" indent="0" algn="l">
@@ -14493,17 +16155,20 @@
               <a:buNone/>
             </a:pPr>
             <a:r>
-              <a:rPr lang="en-US" sz="850" dirty="0">
+              <a:rPr lang="en-US" sz="1400" dirty="0">
                 <a:solidFill>
                   <a:srgbClr val="1B2A41"/>
                 </a:solidFill>
                 <a:latin typeface="Courier New" pitchFamily="49" charset="0"/>
                 <a:ea typeface="Courier New" pitchFamily="49" charset="-122"/>
-                <a:cs typeface="Courier New" pitchFamily="49" charset="-120"/>
+                <a:cs typeface="Courier New" panose="02070309020205020404" pitchFamily="49" charset="0"/>
               </a:rPr>
               <a:t>- status: str, missing=1, unique=1  [constant]</a:t>
             </a:r>
-            <a:endParaRPr lang="en-US" sz="850" dirty="0"/>
+            <a:endParaRPr lang="en-US" sz="1400" dirty="0">
+              <a:latin typeface="Courier New" panose="02070309020205020404" pitchFamily="49" charset="0"/>
+              <a:cs typeface="Courier New" panose="02070309020205020404" pitchFamily="49" charset="0"/>
+            </a:endParaRPr>
           </a:p>
           <a:p>
             <a:pPr marL="0" indent="0" algn="l">
@@ -14513,17 +16178,20 @@
               <a:buNone/>
             </a:pPr>
             <a:r>
-              <a:rPr lang="en-US" sz="850" dirty="0">
+              <a:rPr lang="en-US" sz="1400" dirty="0">
                 <a:solidFill>
                   <a:srgbClr val="1B2A41"/>
                 </a:solidFill>
                 <a:latin typeface="Courier New" pitchFamily="49" charset="0"/>
                 <a:ea typeface="Courier New" pitchFamily="49" charset="-122"/>
-                <a:cs typeface="Courier New" pitchFamily="49" charset="-120"/>
+                <a:cs typeface="Courier New" panose="02070309020205020404" pitchFamily="49" charset="0"/>
               </a:rPr>
               <a:t>- notes: str, missing=156, unique=3</a:t>
             </a:r>
-            <a:endParaRPr lang="en-US" sz="850" dirty="0"/>
+            <a:endParaRPr lang="en-US" sz="1400" dirty="0">
+              <a:latin typeface="Courier New" panose="02070309020205020404" pitchFamily="49" charset="0"/>
+              <a:cs typeface="Courier New" panose="02070309020205020404" pitchFamily="49" charset="0"/>
+            </a:endParaRPr>
           </a:p>
           <a:p>
             <a:pPr marL="0" indent="0" algn="l">
@@ -14533,17 +16201,20 @@
               <a:buNone/>
             </a:pPr>
             <a:r>
-              <a:rPr lang="en-US" sz="850" dirty="0">
+              <a:rPr lang="en-US" sz="1400" dirty="0">
                 <a:solidFill>
                   <a:srgbClr val="1B2A41"/>
                 </a:solidFill>
                 <a:latin typeface="Courier New" pitchFamily="49" charset="0"/>
                 <a:ea typeface="Courier New" pitchFamily="49" charset="-122"/>
-                <a:cs typeface="Courier New" pitchFamily="49" charset="-120"/>
+                <a:cs typeface="Courier New" panose="02070309020205020404" pitchFamily="49" charset="0"/>
               </a:rPr>
               <a:t>Duplicate columns: customer_id and customer_ref</a:t>
             </a:r>
-            <a:endParaRPr lang="en-US" sz="850" dirty="0"/>
+            <a:endParaRPr lang="en-US" sz="1400" dirty="0">
+              <a:latin typeface="Courier New" panose="02070309020205020404" pitchFamily="49" charset="0"/>
+              <a:cs typeface="Courier New" panose="02070309020205020404" pitchFamily="49" charset="0"/>
+            </a:endParaRPr>
           </a:p>
         </p:txBody>
       </p:sp>
@@ -14683,6 +16354,13 @@
   <p:clrMapOvr>
     <a:masterClrMapping/>
   </p:clrMapOvr>
+  <p:timing>
+    <p:tnLst>
+      <p:par>
+        <p:cTn id="1" dur="indefinite" restart="never" nodeType="tmRoot"/>
+      </p:par>
+    </p:tnLst>
+  </p:timing>
 </p:sld>
 </file>
 
@@ -14775,7 +16453,7 @@
         </p:nvGraphicFramePr>
         <p:xfrm>
           <a:off x="825500" y="1473200"/>
-          <a:ext cx="10553700" cy="2702074"/>
+          <a:ext cx="10553700" cy="2702077"/>
         </p:xfrm>
         <a:graphic>
           <a:graphicData uri="http://schemas.openxmlformats.org/drawingml/2006/table">
@@ -14785,14 +16463,14 @@
                 <a:gridCol w="5276850">
                   <a:extLst>
                     <a:ext uri="{9D8B030D-6E8A-4147-A177-3AD203B41FA5}">
-                      <a16:colId xmlns:a16="http://schemas.microsoft.com/office/drawing/2014/main" val="20000"/>
+                      <a16:colId xmlns="" xmlns:a16="http://schemas.microsoft.com/office/drawing/2014/main" val="20000"/>
                     </a:ext>
                   </a:extLst>
                 </a:gridCol>
                 <a:gridCol w="5276850">
                   <a:extLst>
                     <a:ext uri="{9D8B030D-6E8A-4147-A177-3AD203B41FA5}">
-                      <a16:colId xmlns:a16="http://schemas.microsoft.com/office/drawing/2014/main" val="20001"/>
+                      <a16:colId xmlns="" xmlns:a16="http://schemas.microsoft.com/office/drawing/2014/main" val="20001"/>
                     </a:ext>
                   </a:extLst>
                 </a:gridCol>
@@ -14942,7 +16620,7 @@
                 </a:tc>
                 <a:extLst>
                   <a:ext uri="{0D108BD9-81ED-4DB2-BD59-A6C34878D82A}">
-                    <a16:rowId xmlns:a16="http://schemas.microsoft.com/office/drawing/2014/main" val="10000"/>
+                    <a16:rowId xmlns="" xmlns:a16="http://schemas.microsoft.com/office/drawing/2014/main" val="10000"/>
                   </a:ext>
                 </a:extLst>
               </a:tr>
@@ -15085,7 +16763,7 @@
                 </a:tc>
                 <a:extLst>
                   <a:ext uri="{0D108BD9-81ED-4DB2-BD59-A6C34878D82A}">
-                    <a16:rowId xmlns:a16="http://schemas.microsoft.com/office/drawing/2014/main" val="10001"/>
+                    <a16:rowId xmlns="" xmlns:a16="http://schemas.microsoft.com/office/drawing/2014/main" val="10001"/>
                   </a:ext>
                 </a:extLst>
               </a:tr>
@@ -15228,7 +16906,7 @@
                 </a:tc>
                 <a:extLst>
                   <a:ext uri="{0D108BD9-81ED-4DB2-BD59-A6C34878D82A}">
-                    <a16:rowId xmlns:a16="http://schemas.microsoft.com/office/drawing/2014/main" val="10002"/>
+                    <a16:rowId xmlns="" xmlns:a16="http://schemas.microsoft.com/office/drawing/2014/main" val="10002"/>
                   </a:ext>
                 </a:extLst>
               </a:tr>
@@ -15371,7 +17049,7 @@
                 </a:tc>
                 <a:extLst>
                   <a:ext uri="{0D108BD9-81ED-4DB2-BD59-A6C34878D82A}">
-                    <a16:rowId xmlns:a16="http://schemas.microsoft.com/office/drawing/2014/main" val="10003"/>
+                    <a16:rowId xmlns="" xmlns:a16="http://schemas.microsoft.com/office/drawing/2014/main" val="10003"/>
                   </a:ext>
                 </a:extLst>
               </a:tr>
@@ -15514,7 +17192,7 @@
                 </a:tc>
                 <a:extLst>
                   <a:ext uri="{0D108BD9-81ED-4DB2-BD59-A6C34878D82A}">
-                    <a16:rowId xmlns:a16="http://schemas.microsoft.com/office/drawing/2014/main" val="10004"/>
+                    <a16:rowId xmlns="" xmlns:a16="http://schemas.microsoft.com/office/drawing/2014/main" val="10004"/>
                   </a:ext>
                 </a:extLst>
               </a:tr>
@@ -15657,7 +17335,7 @@
                 </a:tc>
                 <a:extLst>
                   <a:ext uri="{0D108BD9-81ED-4DB2-BD59-A6C34878D82A}">
-                    <a16:rowId xmlns:a16="http://schemas.microsoft.com/office/drawing/2014/main" val="10005"/>
+                    <a16:rowId xmlns="" xmlns:a16="http://schemas.microsoft.com/office/drawing/2014/main" val="10005"/>
                   </a:ext>
                 </a:extLst>
               </a:tr>
@@ -15800,7 +17478,7 @@
                 </a:tc>
                 <a:extLst>
                   <a:ext uri="{0D108BD9-81ED-4DB2-BD59-A6C34878D82A}">
-                    <a16:rowId xmlns:a16="http://schemas.microsoft.com/office/drawing/2014/main" val="10006"/>
+                    <a16:rowId xmlns="" xmlns:a16="http://schemas.microsoft.com/office/drawing/2014/main" val="10006"/>
                   </a:ext>
                 </a:extLst>
               </a:tr>
@@ -15857,6 +17535,13 @@
   <p:clrMapOvr>
     <a:masterClrMapping/>
   </p:clrMapOvr>
+  <p:timing>
+    <p:tnLst>
+      <p:par>
+        <p:cTn id="1" dur="indefinite" restart="never" nodeType="tmRoot"/>
+      </p:par>
+    </p:tnLst>
+  </p:timing>
 </p:sld>
 </file>
 
@@ -16077,7 +17762,7 @@
         </p:nvGraphicFramePr>
         <p:xfrm>
           <a:off x="825500" y="3397052"/>
-          <a:ext cx="10553700" cy="1077962"/>
+          <a:ext cx="10553700" cy="1077963"/>
         </p:xfrm>
         <a:graphic>
           <a:graphicData uri="http://schemas.openxmlformats.org/drawingml/2006/table">
@@ -16087,14 +17772,14 @@
                 <a:gridCol w="5276850">
                   <a:extLst>
                     <a:ext uri="{9D8B030D-6E8A-4147-A177-3AD203B41FA5}">
-                      <a16:colId xmlns:a16="http://schemas.microsoft.com/office/drawing/2014/main" val="20000"/>
+                      <a16:colId xmlns="" xmlns:a16="http://schemas.microsoft.com/office/drawing/2014/main" val="20000"/>
                     </a:ext>
                   </a:extLst>
                 </a:gridCol>
                 <a:gridCol w="5276850">
                   <a:extLst>
                     <a:ext uri="{9D8B030D-6E8A-4147-A177-3AD203B41FA5}">
-                      <a16:colId xmlns:a16="http://schemas.microsoft.com/office/drawing/2014/main" val="20001"/>
+                      <a16:colId xmlns="" xmlns:a16="http://schemas.microsoft.com/office/drawing/2014/main" val="20001"/>
                     </a:ext>
                   </a:extLst>
                 </a:gridCol>
@@ -16244,7 +17929,7 @@
                 </a:tc>
                 <a:extLst>
                   <a:ext uri="{0D108BD9-81ED-4DB2-BD59-A6C34878D82A}">
-                    <a16:rowId xmlns:a16="http://schemas.microsoft.com/office/drawing/2014/main" val="10000"/>
+                    <a16:rowId xmlns="" xmlns:a16="http://schemas.microsoft.com/office/drawing/2014/main" val="10000"/>
                   </a:ext>
                 </a:extLst>
               </a:tr>
@@ -16387,7 +18072,7 @@
                 </a:tc>
                 <a:extLst>
                   <a:ext uri="{0D108BD9-81ED-4DB2-BD59-A6C34878D82A}">
-                    <a16:rowId xmlns:a16="http://schemas.microsoft.com/office/drawing/2014/main" val="10001"/>
+                    <a16:rowId xmlns="" xmlns:a16="http://schemas.microsoft.com/office/drawing/2014/main" val="10001"/>
                   </a:ext>
                 </a:extLst>
               </a:tr>
@@ -16530,7 +18215,7 @@
                 </a:tc>
                 <a:extLst>
                   <a:ext uri="{0D108BD9-81ED-4DB2-BD59-A6C34878D82A}">
-                    <a16:rowId xmlns:a16="http://schemas.microsoft.com/office/drawing/2014/main" val="10002"/>
+                    <a16:rowId xmlns="" xmlns:a16="http://schemas.microsoft.com/office/drawing/2014/main" val="10002"/>
                   </a:ext>
                 </a:extLst>
               </a:tr>
@@ -16631,6 +18316,13 @@
   <p:clrMapOvr>
     <a:masterClrMapping/>
   </p:clrMapOvr>
+  <p:timing>
+    <p:tnLst>
+      <p:par>
+        <p:cTn id="1" dur="indefinite" restart="never" nodeType="tmRoot"/>
+      </p:par>
+    </p:tnLst>
+  </p:timing>
 </p:sld>
 </file>
 
@@ -17209,6 +18901,13 @@
   <p:clrMapOvr>
     <a:masterClrMapping/>
   </p:clrMapOvr>
+  <p:timing>
+    <p:tnLst>
+      <p:par>
+        <p:cTn id="1" dur="indefinite" restart="never" nodeType="tmRoot"/>
+      </p:par>
+    </p:tnLst>
+  </p:timing>
 </p:sld>
 </file>
 
@@ -17944,6 +19643,13 @@
   <p:clrMapOvr>
     <a:masterClrMapping/>
   </p:clrMapOvr>
+  <p:timing>
+    <p:tnLst>
+      <p:par>
+        <p:cTn id="1" dur="indefinite" restart="never" nodeType="tmRoot"/>
+      </p:par>
+    </p:tnLst>
+  </p:timing>
 </p:sld>
 </file>
 
@@ -18601,6 +20307,13 @@
   <p:clrMapOvr>
     <a:masterClrMapping/>
   </p:clrMapOvr>
+  <p:timing>
+    <p:tnLst>
+      <p:par>
+        <p:cTn id="1" dur="indefinite" restart="never" nodeType="tmRoot"/>
+      </p:par>
+    </p:tnLst>
+  </p:timing>
 </p:sld>
 </file>
 
@@ -18703,14 +20416,14 @@
                 <a:gridCol w="5276850">
                   <a:extLst>
                     <a:ext uri="{9D8B030D-6E8A-4147-A177-3AD203B41FA5}">
-                      <a16:colId xmlns:a16="http://schemas.microsoft.com/office/drawing/2014/main" val="20000"/>
+                      <a16:colId xmlns="" xmlns:a16="http://schemas.microsoft.com/office/drawing/2014/main" val="20000"/>
                     </a:ext>
                   </a:extLst>
                 </a:gridCol>
                 <a:gridCol w="5276850">
                   <a:extLst>
                     <a:ext uri="{9D8B030D-6E8A-4147-A177-3AD203B41FA5}">
-                      <a16:colId xmlns:a16="http://schemas.microsoft.com/office/drawing/2014/main" val="20001"/>
+                      <a16:colId xmlns="" xmlns:a16="http://schemas.microsoft.com/office/drawing/2014/main" val="20001"/>
                     </a:ext>
                   </a:extLst>
                 </a:gridCol>
@@ -18860,7 +20573,7 @@
                 </a:tc>
                 <a:extLst>
                   <a:ext uri="{0D108BD9-81ED-4DB2-BD59-A6C34878D82A}">
-                    <a16:rowId xmlns:a16="http://schemas.microsoft.com/office/drawing/2014/main" val="10000"/>
+                    <a16:rowId xmlns="" xmlns:a16="http://schemas.microsoft.com/office/drawing/2014/main" val="10000"/>
                   </a:ext>
                 </a:extLst>
               </a:tr>
@@ -19003,7 +20716,7 @@
                 </a:tc>
                 <a:extLst>
                   <a:ext uri="{0D108BD9-81ED-4DB2-BD59-A6C34878D82A}">
-                    <a16:rowId xmlns:a16="http://schemas.microsoft.com/office/drawing/2014/main" val="10001"/>
+                    <a16:rowId xmlns="" xmlns:a16="http://schemas.microsoft.com/office/drawing/2014/main" val="10001"/>
                   </a:ext>
                 </a:extLst>
               </a:tr>
@@ -19146,7 +20859,7 @@
                 </a:tc>
                 <a:extLst>
                   <a:ext uri="{0D108BD9-81ED-4DB2-BD59-A6C34878D82A}">
-                    <a16:rowId xmlns:a16="http://schemas.microsoft.com/office/drawing/2014/main" val="10002"/>
+                    <a16:rowId xmlns="" xmlns:a16="http://schemas.microsoft.com/office/drawing/2014/main" val="10002"/>
                   </a:ext>
                 </a:extLst>
               </a:tr>
@@ -19289,7 +21002,7 @@
                 </a:tc>
                 <a:extLst>
                   <a:ext uri="{0D108BD9-81ED-4DB2-BD59-A6C34878D82A}">
-                    <a16:rowId xmlns:a16="http://schemas.microsoft.com/office/drawing/2014/main" val="10003"/>
+                    <a16:rowId xmlns="" xmlns:a16="http://schemas.microsoft.com/office/drawing/2014/main" val="10003"/>
                   </a:ext>
                 </a:extLst>
               </a:tr>
@@ -19432,7 +21145,7 @@
                 </a:tc>
                 <a:extLst>
                   <a:ext uri="{0D108BD9-81ED-4DB2-BD59-A6C34878D82A}">
-                    <a16:rowId xmlns:a16="http://schemas.microsoft.com/office/drawing/2014/main" val="10004"/>
+                    <a16:rowId xmlns="" xmlns:a16="http://schemas.microsoft.com/office/drawing/2014/main" val="10004"/>
                   </a:ext>
                 </a:extLst>
               </a:tr>
@@ -19533,6 +21246,13 @@
   <p:clrMapOvr>
     <a:masterClrMapping/>
   </p:clrMapOvr>
+  <p:timing>
+    <p:tnLst>
+      <p:par>
+        <p:cTn id="1" dur="indefinite" restart="never" nodeType="tmRoot"/>
+      </p:par>
+    </p:tnLst>
+  </p:timing>
 </p:sld>
 </file>
 
@@ -19870,6 +21590,13 @@
   <p:clrMapOvr>
     <a:masterClrMapping/>
   </p:clrMapOvr>
+  <p:timing>
+    <p:tnLst>
+      <p:par>
+        <p:cTn id="1" dur="indefinite" restart="never" nodeType="tmRoot"/>
+      </p:par>
+    </p:tnLst>
+  </p:timing>
 </p:sld>
 </file>
 
@@ -20167,6 +21894,13 @@
   <p:clrMapOvr>
     <a:masterClrMapping/>
   </p:clrMapOvr>
+  <p:timing>
+    <p:tnLst>
+      <p:par>
+        <p:cTn id="1" dur="indefinite" restart="never" nodeType="tmRoot"/>
+      </p:par>
+    </p:tnLst>
+  </p:timing>
 </p:sld>
 </file>
 
@@ -20266,7 +22000,7 @@
         </p:spPr>
         <p:txBody>
           <a:bodyPr wrap="square" lIns="173442" tIns="173442" rIns="0" bIns="148042" rtlCol="0" anchor="t">
-            <a:normAutofit/>
+            <a:noAutofit/>
           </a:bodyPr>
           <a:lstStyle/>
           <a:p>
@@ -20277,17 +22011,20 @@
               <a:buNone/>
             </a:pPr>
             <a:r>
-              <a:rPr lang="en-US" sz="1350" dirty="0">
+              <a:rPr lang="en-US" sz="1400" dirty="0">
                 <a:solidFill>
                   <a:srgbClr val="F7F5EF"/>
                 </a:solidFill>
-                <a:latin typeface="Courier New" pitchFamily="49" charset="0"/>
-                <a:ea typeface="Courier New" pitchFamily="49" charset="-122"/>
-                <a:cs typeface="Courier New" pitchFamily="49" charset="-120"/>
+                <a:latin typeface="Courier New" panose="02070309020205020404" pitchFamily="49" charset="0"/>
+                <a:ea typeface="Courier New" pitchFamily="49" charset="-122"/>
+                <a:cs typeface="Courier New" panose="02070309020205020404" pitchFamily="49" charset="0"/>
               </a:rPr>
               <a:t>amounts = [1200, 450, 3000, 80, 950, 5000]</a:t>
             </a:r>
-            <a:endParaRPr lang="en-US" sz="1350" dirty="0"/>
+            <a:endParaRPr lang="en-US" sz="1400" dirty="0">
+              <a:latin typeface="Courier New" panose="02070309020205020404" pitchFamily="49" charset="0"/>
+              <a:cs typeface="Courier New" panose="02070309020205020404" pitchFamily="49" charset="0"/>
+            </a:endParaRPr>
           </a:p>
           <a:p>
             <a:pPr marL="0" indent="0" algn="l">
@@ -20297,17 +22034,20 @@
               <a:buNone/>
             </a:pPr>
             <a:r>
-              <a:rPr lang="en-US" sz="1350" dirty="0">
+              <a:rPr lang="en-US" sz="1400" dirty="0">
                 <a:solidFill>
                   <a:srgbClr val="F7F5EF"/>
                 </a:solidFill>
                 <a:latin typeface="Courier New" pitchFamily="49" charset="0"/>
                 <a:ea typeface="Courier New" pitchFamily="49" charset="-122"/>
-                <a:cs typeface="Courier New" pitchFamily="49" charset="-120"/>
+                <a:cs typeface="Courier New" panose="02070309020205020404" pitchFamily="49" charset="0"/>
               </a:rPr>
               <a:t>amounts[0], amounts[-1]              # 1200, 5000</a:t>
             </a:r>
-            <a:endParaRPr lang="en-US" sz="1350" dirty="0"/>
+            <a:endParaRPr lang="en-US" sz="1400" dirty="0">
+              <a:latin typeface="Courier New" panose="02070309020205020404" pitchFamily="49" charset="0"/>
+              <a:cs typeface="Courier New" panose="02070309020205020404" pitchFamily="49" charset="0"/>
+            </a:endParaRPr>
           </a:p>
           <a:p>
             <a:pPr marL="0" indent="0" algn="l">
@@ -20317,17 +22057,20 @@
               <a:buNone/>
             </a:pPr>
             <a:r>
-              <a:rPr lang="en-US" sz="1350" dirty="0">
+              <a:rPr lang="en-US" sz="1400" dirty="0">
                 <a:solidFill>
                   <a:srgbClr val="F7F5EF"/>
                 </a:solidFill>
                 <a:latin typeface="Courier New" pitchFamily="49" charset="0"/>
                 <a:ea typeface="Courier New" pitchFamily="49" charset="-122"/>
-                <a:cs typeface="Courier New" pitchFamily="49" charset="-120"/>
+                <a:cs typeface="Courier New" panose="02070309020205020404" pitchFamily="49" charset="0"/>
               </a:rPr>
               <a:t>amounts[1:4]                         # [450, 3000, 80]</a:t>
             </a:r>
-            <a:endParaRPr lang="en-US" sz="1350" dirty="0"/>
+            <a:endParaRPr lang="en-US" sz="1400" dirty="0">
+              <a:latin typeface="Courier New" panose="02070309020205020404" pitchFamily="49" charset="0"/>
+              <a:cs typeface="Courier New" panose="02070309020205020404" pitchFamily="49" charset="0"/>
+            </a:endParaRPr>
           </a:p>
           <a:p>
             <a:pPr marL="0" indent="0" algn="l">
@@ -20337,17 +22080,20 @@
               <a:buNone/>
             </a:pPr>
             <a:r>
-              <a:rPr lang="en-US" sz="1350" dirty="0">
+              <a:rPr lang="en-US" sz="1400" dirty="0">
                 <a:solidFill>
                   <a:srgbClr val="F7F5EF"/>
                 </a:solidFill>
                 <a:latin typeface="Courier New" pitchFamily="49" charset="0"/>
                 <a:ea typeface="Courier New" pitchFamily="49" charset="-122"/>
-                <a:cs typeface="Courier New" pitchFamily="49" charset="-120"/>
+                <a:cs typeface="Courier New" panose="02070309020205020404" pitchFamily="49" charset="0"/>
               </a:rPr>
               <a:t>big = [a for a in amounts if a &gt; 1000]   # [1200, 3000, 5000]</a:t>
             </a:r>
-            <a:endParaRPr lang="en-US" sz="1350" dirty="0"/>
+            <a:endParaRPr lang="en-US" sz="1400" dirty="0">
+              <a:latin typeface="Courier New" panose="02070309020205020404" pitchFamily="49" charset="0"/>
+              <a:cs typeface="Courier New" panose="02070309020205020404" pitchFamily="49" charset="0"/>
+            </a:endParaRPr>
           </a:p>
           <a:p>
             <a:pPr marL="0" indent="0" algn="l">
@@ -20357,17 +22103,20 @@
               <a:buNone/>
             </a:pPr>
             <a:r>
-              <a:rPr lang="en-US" sz="1350" dirty="0">
+              <a:rPr lang="en-US" sz="1400" dirty="0">
                 <a:solidFill>
                   <a:srgbClr val="F7F5EF"/>
                 </a:solidFill>
                 <a:latin typeface="Courier New" pitchFamily="49" charset="0"/>
                 <a:ea typeface="Courier New" pitchFamily="49" charset="-122"/>
-                <a:cs typeface="Courier New" pitchFamily="49" charset="-120"/>
+                <a:cs typeface="Courier New" panose="02070309020205020404" pitchFamily="49" charset="0"/>
               </a:rPr>
               <a:t>sorted(amounts, reverse=True)[:3]    # [5000, 3000, 1200]</a:t>
             </a:r>
-            <a:endParaRPr lang="en-US" sz="1350" dirty="0"/>
+            <a:endParaRPr lang="en-US" sz="1400" dirty="0">
+              <a:latin typeface="Courier New" panose="02070309020205020404" pitchFamily="49" charset="0"/>
+              <a:cs typeface="Courier New" panose="02070309020205020404" pitchFamily="49" charset="0"/>
+            </a:endParaRPr>
           </a:p>
         </p:txBody>
       </p:sp>
@@ -20464,6 +22213,13 @@
   <p:clrMapOvr>
     <a:masterClrMapping/>
   </p:clrMapOvr>
+  <p:timing>
+    <p:tnLst>
+      <p:par>
+        <p:cTn id="1" dur="indefinite" restart="never" nodeType="tmRoot"/>
+      </p:par>
+    </p:tnLst>
+  </p:timing>
 </p:sld>
 </file>
 
@@ -20801,6 +22557,13 @@
   <p:clrMapOvr>
     <a:masterClrMapping/>
   </p:clrMapOvr>
+  <p:timing>
+    <p:tnLst>
+      <p:par>
+        <p:cTn id="1" dur="indefinite" restart="never" nodeType="tmRoot"/>
+      </p:par>
+    </p:tnLst>
+  </p:timing>
 </p:sld>
 </file>
 

</xml_diff>